<commit_message>
Refine spine navigation and P2P/program layouts
Update Claude collaboration notes, pillar synthesis, presentations, and new P2P/program overview surfaces.

Made-with: Cursor
</commit_message>
<xml_diff>
--- a/outputs/Audit_Committee_ERP_Controls_Mar2026.pptx
+++ b/outputs/Audit_Committee_ERP_Controls_Mar2026.pptx
@@ -6,6 +6,9 @@
   </p:sldMasterIdLst>
   <p:sldIdLst>
     <p:sldId id="256" r:id="rId2"/>
+    <p:sldId id="262" r:id="rId13"/>
+    <p:sldId id="263" r:id="rId14"/>
+    <p:sldId id="264" r:id="rId15"/>
     <p:sldId id="257" r:id="rId3"/>
     <p:sldId id="258" r:id="rId4"/>
     <p:sldId id="259" r:id="rId5"/>
@@ -2000,7 +2003,7 @@
 </file>
 
 <file path=ppt/slides/slide2.xml><?xml version="1.0" encoding="utf-8"?>
-<p:sld xmlns:a="http://schemas.openxmlformats.org/drawingml/2006/main" xmlns:r="http://schemas.openxmlformats.org/officeDocument/2006/relationships" xmlns:p="http://schemas.openxmlformats.org/presentationml/2006/main">
+<p:sld xmlns:a="http://schemas.openxmlformats.org/drawingml/2006/main" xmlns:p="http://schemas.openxmlformats.org/presentationml/2006/main">
   <p:cSld name="Slide 2">
     <p:bg>
       <p:bgPr>
@@ -2248,7 +2251,7 @@
                 <a:ea typeface="Calibri" pitchFamily="34" charset="-122"/>
                 <a:cs typeface="Calibri" pitchFamily="34" charset="-120"/>
               </a:rPr>
-              <a:t>2 / 6</a:t>
+              <a:t>5 / 9</a:t>
             </a:r>
             <a:endParaRPr lang="en-US" sz="900" dirty="0"/>
           </a:p>
@@ -3630,7 +3633,7 @@
 </file>
 
 <file path=ppt/slides/slide3.xml><?xml version="1.0" encoding="utf-8"?>
-<p:sld xmlns:a="http://schemas.openxmlformats.org/drawingml/2006/main" xmlns:r="http://schemas.openxmlformats.org/officeDocument/2006/relationships" xmlns:p="http://schemas.openxmlformats.org/presentationml/2006/main">
+<p:sld xmlns:a="http://schemas.openxmlformats.org/drawingml/2006/main" xmlns:p="http://schemas.openxmlformats.org/presentationml/2006/main">
   <p:cSld name="Slide 3">
     <p:bg>
       <p:bgPr>
@@ -3878,7 +3881,7 @@
                 <a:ea typeface="Calibri" pitchFamily="34" charset="-122"/>
                 <a:cs typeface="Calibri" pitchFamily="34" charset="-120"/>
               </a:rPr>
-              <a:t>3 / 6</a:t>
+              <a:t>6 / 9</a:t>
             </a:r>
             <a:endParaRPr lang="en-US" sz="900" dirty="0"/>
           </a:p>
@@ -5084,7 +5087,7 @@
 </file>
 
 <file path=ppt/slides/slide4.xml><?xml version="1.0" encoding="utf-8"?>
-<p:sld xmlns:a="http://schemas.openxmlformats.org/drawingml/2006/main" xmlns:r="http://schemas.openxmlformats.org/officeDocument/2006/relationships" xmlns:p="http://schemas.openxmlformats.org/presentationml/2006/main">
+<p:sld xmlns:a="http://schemas.openxmlformats.org/drawingml/2006/main" xmlns:p="http://schemas.openxmlformats.org/presentationml/2006/main">
   <p:cSld name="Slide 4">
     <p:bg>
       <p:bgPr>
@@ -5332,7 +5335,7 @@
                 <a:ea typeface="Calibri" pitchFamily="34" charset="-122"/>
                 <a:cs typeface="Calibri" pitchFamily="34" charset="-120"/>
               </a:rPr>
-              <a:t>4 / 6</a:t>
+              <a:t>7 / 9</a:t>
             </a:r>
             <a:endParaRPr lang="en-US" sz="900" dirty="0"/>
           </a:p>
@@ -6260,7 +6263,7 @@
 </file>
 
 <file path=ppt/slides/slide5.xml><?xml version="1.0" encoding="utf-8"?>
-<p:sld xmlns:a="http://schemas.openxmlformats.org/drawingml/2006/main" xmlns:r="http://schemas.openxmlformats.org/officeDocument/2006/relationships" xmlns:p="http://schemas.openxmlformats.org/presentationml/2006/main">
+<p:sld xmlns:a="http://schemas.openxmlformats.org/drawingml/2006/main" xmlns:p="http://schemas.openxmlformats.org/presentationml/2006/main">
   <p:cSld name="Slide 5">
     <p:bg>
       <p:bgPr>
@@ -6508,7 +6511,7 @@
                 <a:ea typeface="Calibri" pitchFamily="34" charset="-122"/>
                 <a:cs typeface="Calibri" pitchFamily="34" charset="-120"/>
               </a:rPr>
-              <a:t>5 / 6</a:t>
+              <a:t>8 / 9</a:t>
             </a:r>
             <a:endParaRPr lang="en-US" sz="900" dirty="0"/>
           </a:p>
@@ -7129,425 +7132,6 @@
               <a:t>Slippage against critical control deficiencies triggers defined escalation. Audit committee notified monthly on at-risk items.</a:t>
             </a:r>
             <a:endParaRPr lang="en-US" sz="1000" dirty="0"/>
-          </a:p>
-        </p:txBody>
-      </p:sp>
-      <p:sp>
-        <p:nvSpPr>
-          <p:cNvPr id="27" name="Shape 25"/>
-          <p:cNvSpPr/>
-          <p:nvPr/>
-        </p:nvSpPr>
-        <p:spPr>
-          <a:xfrm>
-            <a:off x="5760720" y="1737360"/>
-            <a:ext cx="2926080" cy="2944368"/>
-          </a:xfrm>
-          <a:prstGeom prst="rect">
-            <a:avLst/>
-          </a:prstGeom>
-          <a:solidFill>
-            <a:srgbClr val="0A1A1A"/>
-          </a:solidFill>
-          <a:ln w="12700">
-            <a:solidFill>
-              <a:srgbClr val="F59E0B"/>
-            </a:solidFill>
-            <a:prstDash val="solid"/>
-          </a:ln>
-          <a:effectLst>
-            <a:outerShdw sx="100000" sy="100000" kx="0" ky="0" algn="bl" rotWithShape="0" blurRad="127000" dist="38100" dir="8100000">
-              <a:srgbClr val="000000">
-                <a:alpha val="30000"/>
-              </a:srgbClr>
-            </a:outerShdw>
-          </a:effectLst>
-        </p:spPr>
-      </p:sp>
-      <p:sp>
-        <p:nvSpPr>
-          <p:cNvPr id="28" name="Text 26"/>
-          <p:cNvSpPr/>
-          <p:nvPr/>
-        </p:nvSpPr>
-        <p:spPr>
-          <a:xfrm>
-            <a:off x="5897880" y="1792224"/>
-            <a:ext cx="2651760" cy="274320"/>
-          </a:xfrm>
-          <a:prstGeom prst="rect">
-            <a:avLst/>
-          </a:prstGeom>
-          <a:noFill/>
-          <a:ln/>
-        </p:spPr>
-        <p:txBody>
-          <a:bodyPr wrap="square" lIns="0" tIns="0" rIns="0" bIns="0" rtlCol="0" anchor="ctr"/>
-          <a:lstStyle/>
-          <a:p>
-            <a:pPr algn="l" indent="0" marL="0">
-              <a:buNone/>
-            </a:pPr>
-            <a:r>
-              <a:rPr lang="en-US" sz="1000" b="1" spc="100" kern="0" dirty="0">
-                <a:solidFill>
-                  <a:srgbClr val="F59E0B"/>
-                </a:solidFill>
-                <a:latin typeface="Calibri" pitchFamily="34" charset="0"/>
-                <a:ea typeface="Calibri" pitchFamily="34" charset="-122"/>
-                <a:cs typeface="Calibri" pitchFamily="34" charset="-120"/>
-              </a:rPr>
-              <a:t>⚠  OPEN DATA GAPS</a:t>
-            </a:r>
-            <a:endParaRPr lang="en-US" sz="1000" dirty="0"/>
-          </a:p>
-        </p:txBody>
-      </p:sp>
-      <p:sp>
-        <p:nvSpPr>
-          <p:cNvPr id="29" name="Text 27"/>
-          <p:cNvSpPr/>
-          <p:nvPr/>
-        </p:nvSpPr>
-        <p:spPr>
-          <a:xfrm>
-            <a:off x="5897880" y="2066544"/>
-            <a:ext cx="2651760" cy="201168"/>
-          </a:xfrm>
-          <a:prstGeom prst="rect">
-            <a:avLst/>
-          </a:prstGeom>
-          <a:noFill/>
-          <a:ln/>
-        </p:spPr>
-        <p:txBody>
-          <a:bodyPr wrap="square" lIns="0" tIns="0" rIns="0" bIns="0" rtlCol="0" anchor="ctr"/>
-          <a:lstStyle/>
-          <a:p>
-            <a:pPr algn="l" indent="0" marL="0">
-              <a:buNone/>
-            </a:pPr>
-            <a:r>
-              <a:rPr lang="en-US" sz="900" dirty="0">
-                <a:solidFill>
-                  <a:srgbClr val="94A3B8"/>
-                </a:solidFill>
-                <a:latin typeface="Calibri" pitchFamily="34" charset="0"/>
-                <a:ea typeface="Calibri" pitchFamily="34" charset="-122"/>
-                <a:cs typeface="Calibri" pitchFamily="34" charset="-120"/>
-              </a:rPr>
-              <a:t>Required before deck is presentation-ready:</a:t>
-            </a:r>
-            <a:endParaRPr lang="en-US" sz="900" dirty="0"/>
-          </a:p>
-        </p:txBody>
-      </p:sp>
-      <p:sp>
-        <p:nvSpPr>
-          <p:cNvPr id="30" name="Shape 28"/>
-          <p:cNvSpPr/>
-          <p:nvPr/>
-        </p:nvSpPr>
-        <p:spPr>
-          <a:xfrm>
-            <a:off x="5897880" y="2322576"/>
-            <a:ext cx="2651760" cy="694944"/>
-          </a:xfrm>
-          <a:prstGeom prst="rect">
-            <a:avLst/>
-          </a:prstGeom>
-          <a:solidFill>
-            <a:srgbClr val="92400E"/>
-          </a:solidFill>
-          <a:ln w="12700">
-            <a:solidFill>
-              <a:srgbClr val="F59E0B"/>
-            </a:solidFill>
-            <a:prstDash val="solid"/>
-          </a:ln>
-        </p:spPr>
-      </p:sp>
-      <p:sp>
-        <p:nvSpPr>
-          <p:cNvPr id="31" name="Text 29"/>
-          <p:cNvSpPr/>
-          <p:nvPr/>
-        </p:nvSpPr>
-        <p:spPr>
-          <a:xfrm>
-            <a:off x="6016752" y="2368296"/>
-            <a:ext cx="2423160" cy="228600"/>
-          </a:xfrm>
-          <a:prstGeom prst="rect">
-            <a:avLst/>
-          </a:prstGeom>
-          <a:noFill/>
-          <a:ln/>
-        </p:spPr>
-        <p:txBody>
-          <a:bodyPr wrap="square" lIns="0" tIns="0" rIns="0" bIns="0" rtlCol="0" anchor="ctr"/>
-          <a:lstStyle/>
-          <a:p>
-            <a:pPr algn="l" indent="0" marL="0">
-              <a:buNone/>
-            </a:pPr>
-            <a:r>
-              <a:rPr lang="en-US" sz="1000" b="1" dirty="0">
-                <a:solidFill>
-                  <a:srgbClr val="F59E0B"/>
-                </a:solidFill>
-                <a:latin typeface="Calibri" pitchFamily="34" charset="0"/>
-                <a:ea typeface="Calibri" pitchFamily="34" charset="-122"/>
-                <a:cs typeface="Calibri" pitchFamily="34" charset="-120"/>
-              </a:rPr>
-              <a:t>• Audit Committee Date</a:t>
-            </a:r>
-            <a:endParaRPr lang="en-US" sz="1000" dirty="0"/>
-          </a:p>
-        </p:txBody>
-      </p:sp>
-      <p:sp>
-        <p:nvSpPr>
-          <p:cNvPr id="32" name="Text 30"/>
-          <p:cNvSpPr/>
-          <p:nvPr/>
-        </p:nvSpPr>
-        <p:spPr>
-          <a:xfrm>
-            <a:off x="6016752" y="2596896"/>
-            <a:ext cx="2423160" cy="384048"/>
-          </a:xfrm>
-          <a:prstGeom prst="rect">
-            <a:avLst/>
-          </a:prstGeom>
-          <a:noFill/>
-          <a:ln/>
-        </p:spPr>
-        <p:txBody>
-          <a:bodyPr wrap="square" lIns="0" tIns="0" rIns="0" bIns="0" rtlCol="0" anchor="t"/>
-          <a:lstStyle/>
-          <a:p>
-            <a:pPr algn="l" indent="0" marL="0">
-              <a:buNone/>
-            </a:pPr>
-            <a:r>
-              <a:rPr lang="en-US" sz="900" dirty="0">
-                <a:solidFill>
-                  <a:srgbClr val="FDE68A"/>
-                </a:solidFill>
-                <a:latin typeface="Calibri" pitchFamily="34" charset="0"/>
-                <a:ea typeface="Calibri" pitchFamily="34" charset="-122"/>
-                <a:cs typeface="Calibri" pitchFamily="34" charset="-120"/>
-              </a:rPr>
-              <a:t>Camille to confirm exact date and time for the audit committee meeting. Deck timing and delivery format TBD.</a:t>
-            </a:r>
-            <a:endParaRPr lang="en-US" sz="900" dirty="0"/>
-          </a:p>
-        </p:txBody>
-      </p:sp>
-      <p:sp>
-        <p:nvSpPr>
-          <p:cNvPr id="33" name="Shape 31"/>
-          <p:cNvSpPr/>
-          <p:nvPr/>
-        </p:nvSpPr>
-        <p:spPr>
-          <a:xfrm>
-            <a:off x="5897880" y="3090672"/>
-            <a:ext cx="2651760" cy="694944"/>
-          </a:xfrm>
-          <a:prstGeom prst="rect">
-            <a:avLst/>
-          </a:prstGeom>
-          <a:solidFill>
-            <a:srgbClr val="92400E"/>
-          </a:solidFill>
-          <a:ln w="12700">
-            <a:solidFill>
-              <a:srgbClr val="F59E0B"/>
-            </a:solidFill>
-            <a:prstDash val="solid"/>
-          </a:ln>
-        </p:spPr>
-      </p:sp>
-      <p:sp>
-        <p:nvSpPr>
-          <p:cNvPr id="34" name="Text 32"/>
-          <p:cNvSpPr/>
-          <p:nvPr/>
-        </p:nvSpPr>
-        <p:spPr>
-          <a:xfrm>
-            <a:off x="6016752" y="3136392"/>
-            <a:ext cx="2423160" cy="228600"/>
-          </a:xfrm>
-          <a:prstGeom prst="rect">
-            <a:avLst/>
-          </a:prstGeom>
-          <a:noFill/>
-          <a:ln/>
-        </p:spPr>
-        <p:txBody>
-          <a:bodyPr wrap="square" lIns="0" tIns="0" rIns="0" bIns="0" rtlCol="0" anchor="ctr"/>
-          <a:lstStyle/>
-          <a:p>
-            <a:pPr algn="l" indent="0" marL="0">
-              <a:buNone/>
-            </a:pPr>
-            <a:r>
-              <a:rPr lang="en-US" sz="1000" b="1" dirty="0">
-                <a:solidFill>
-                  <a:srgbClr val="F59E0B"/>
-                </a:solidFill>
-                <a:latin typeface="Calibri" pitchFamily="34" charset="0"/>
-                <a:ea typeface="Calibri" pitchFamily="34" charset="-122"/>
-                <a:cs typeface="Calibri" pitchFamily="34" charset="-120"/>
-              </a:rPr>
-              <a:t>• Commercial / Timeline Pack</a:t>
-            </a:r>
-            <a:endParaRPr lang="en-US" sz="1000" dirty="0"/>
-          </a:p>
-        </p:txBody>
-      </p:sp>
-      <p:sp>
-        <p:nvSpPr>
-          <p:cNvPr id="35" name="Text 33"/>
-          <p:cNvSpPr/>
-          <p:nvPr/>
-        </p:nvSpPr>
-        <p:spPr>
-          <a:xfrm>
-            <a:off x="6016752" y="3364992"/>
-            <a:ext cx="2423160" cy="384048"/>
-          </a:xfrm>
-          <a:prstGeom prst="rect">
-            <a:avLst/>
-          </a:prstGeom>
-          <a:noFill/>
-          <a:ln/>
-        </p:spPr>
-        <p:txBody>
-          <a:bodyPr wrap="square" lIns="0" tIns="0" rIns="0" bIns="0" rtlCol="0" anchor="t"/>
-          <a:lstStyle/>
-          <a:p>
-            <a:pPr algn="l" indent="0" marL="0">
-              <a:buNone/>
-            </a:pPr>
-            <a:r>
-              <a:rPr lang="en-US" sz="900" dirty="0">
-                <a:solidFill>
-                  <a:srgbClr val="FDE68A"/>
-                </a:solidFill>
-                <a:latin typeface="Calibri" pitchFamily="34" charset="0"/>
-                <a:ea typeface="Calibri" pitchFamily="34" charset="-122"/>
-                <a:cs typeface="Calibri" pitchFamily="34" charset="-120"/>
-              </a:rPr>
-              <a:t>Updated SAP vs. NetSuite financial comparison and timeline elements requested by Camille. Not yet reflected in current financial section.</a:t>
-            </a:r>
-            <a:endParaRPr lang="en-US" sz="900" dirty="0"/>
-          </a:p>
-        </p:txBody>
-      </p:sp>
-      <p:sp>
-        <p:nvSpPr>
-          <p:cNvPr id="36" name="Shape 34"/>
-          <p:cNvSpPr/>
-          <p:nvPr/>
-        </p:nvSpPr>
-        <p:spPr>
-          <a:xfrm>
-            <a:off x="5897880" y="3858768"/>
-            <a:ext cx="2651760" cy="694944"/>
-          </a:xfrm>
-          <a:prstGeom prst="rect">
-            <a:avLst/>
-          </a:prstGeom>
-          <a:solidFill>
-            <a:srgbClr val="92400E"/>
-          </a:solidFill>
-          <a:ln w="12700">
-            <a:solidFill>
-              <a:srgbClr val="F59E0B"/>
-            </a:solidFill>
-            <a:prstDash val="solid"/>
-          </a:ln>
-        </p:spPr>
-      </p:sp>
-      <p:sp>
-        <p:nvSpPr>
-          <p:cNvPr id="37" name="Text 35"/>
-          <p:cNvSpPr/>
-          <p:nvPr/>
-        </p:nvSpPr>
-        <p:spPr>
-          <a:xfrm>
-            <a:off x="6016752" y="3904488"/>
-            <a:ext cx="2423160" cy="228600"/>
-          </a:xfrm>
-          <a:prstGeom prst="rect">
-            <a:avLst/>
-          </a:prstGeom>
-          <a:noFill/>
-          <a:ln/>
-        </p:spPr>
-        <p:txBody>
-          <a:bodyPr wrap="square" lIns="0" tIns="0" rIns="0" bIns="0" rtlCol="0" anchor="ctr"/>
-          <a:lstStyle/>
-          <a:p>
-            <a:pPr algn="l" indent="0" marL="0">
-              <a:buNone/>
-            </a:pPr>
-            <a:r>
-              <a:rPr lang="en-US" sz="1000" b="1" dirty="0">
-                <a:solidFill>
-                  <a:srgbClr val="F59E0B"/>
-                </a:solidFill>
-                <a:latin typeface="Calibri" pitchFamily="34" charset="0"/>
-                <a:ea typeface="Calibri" pitchFamily="34" charset="-122"/>
-                <a:cs typeface="Calibri" pitchFamily="34" charset="-120"/>
-              </a:rPr>
-              <a:t>• Adrian's 3-Slide Pack</a:t>
-            </a:r>
-            <a:endParaRPr lang="en-US" sz="1000" dirty="0"/>
-          </a:p>
-        </p:txBody>
-      </p:sp>
-      <p:sp>
-        <p:nvSpPr>
-          <p:cNvPr id="38" name="Text 36"/>
-          <p:cNvSpPr/>
-          <p:nvPr/>
-        </p:nvSpPr>
-        <p:spPr>
-          <a:xfrm>
-            <a:off x="6016752" y="4133088"/>
-            <a:ext cx="2423160" cy="384048"/>
-          </a:xfrm>
-          <a:prstGeom prst="rect">
-            <a:avLst/>
-          </a:prstGeom>
-          <a:noFill/>
-          <a:ln/>
-        </p:spPr>
-        <p:txBody>
-          <a:bodyPr wrap="square" lIns="0" tIns="0" rIns="0" bIns="0" rtlCol="0" anchor="t"/>
-          <a:lstStyle/>
-          <a:p>
-            <a:pPr algn="l" indent="0" marL="0">
-              <a:buNone/>
-            </a:pPr>
-            <a:r>
-              <a:rPr lang="en-US" sz="900" dirty="0">
-                <a:solidFill>
-                  <a:srgbClr val="FDE68A"/>
-                </a:solidFill>
-                <a:latin typeface="Calibri" pitchFamily="34" charset="0"/>
-                <a:ea typeface="Calibri" pitchFamily="34" charset="-122"/>
-                <a:cs typeface="Calibri" pitchFamily="34" charset="-120"/>
-              </a:rPr>
-              <a:t>Overview / timeline / financials pack requested by Adrian for audit committee prep. Content to be confirmed and formatted.</a:t>
-            </a:r>
-            <a:endParaRPr lang="en-US" sz="900" dirty="0"/>
           </a:p>
         </p:txBody>
       </p:sp>
@@ -7560,7 +7144,7 @@
 </file>
 
 <file path=ppt/slides/slide6.xml><?xml version="1.0" encoding="utf-8"?>
-<p:sld xmlns:a="http://schemas.openxmlformats.org/drawingml/2006/main" xmlns:r="http://schemas.openxmlformats.org/officeDocument/2006/relationships" xmlns:p="http://schemas.openxmlformats.org/presentationml/2006/main">
+<p:sld xmlns:a="http://schemas.openxmlformats.org/drawingml/2006/main" xmlns:p="http://schemas.openxmlformats.org/presentationml/2006/main">
   <p:cSld name="Slide 6">
     <p:bg>
       <p:bgPr>
@@ -7833,7 +7417,7 @@
                 <a:ea typeface="Calibri" pitchFamily="34" charset="-122"/>
                 <a:cs typeface="Calibri" pitchFamily="34" charset="-120"/>
               </a:rPr>
-              <a:t>6 / 6</a:t>
+              <a:t>9 / 9</a:t>
             </a:r>
             <a:endParaRPr lang="en-US" sz="900" dirty="0"/>
           </a:p>
@@ -8866,6 +8450,2784 @@
               <a:t>Slides due: March 6, 2026  ·  Meeting: March 2026 (date TBD with Camille)  ·  Owner: Mike Markman</a:t>
             </a:r>
             <a:endParaRPr lang="en-US" sz="900" dirty="0"/>
+          </a:p>
+        </p:txBody>
+      </p:sp>
+    </p:spTree>
+  </p:cSld>
+  <p:clrMapOvr>
+    <a:masterClrMapping/>
+  </p:clrMapOvr>
+</p:sld>
+</file>
+
+<file path=ppt/slides/slide7.xml><?xml version="1.0" encoding="utf-8"?>
+<p:sld xmlns:a="http://schemas.openxmlformats.org/drawingml/2006/main" xmlns:r="http://schemas.openxmlformats.org/officeDocument/2006/relationships" xmlns:p="http://schemas.openxmlformats.org/presentationml/2006/main">
+  <p:cSld name="ERP Program Overview">
+    <p:bg>
+      <p:bgPr>
+        <a:solidFill>
+          <a:srgbClr val="080E1C"/>
+        </a:solidFill>
+      </p:bgPr>
+    </p:bg>
+    <p:spTree>
+      <p:nvGrpSpPr>
+        <p:cNvPr id="1" name=""/>
+        <p:cNvGrpSpPr/>
+        <p:nvPr/>
+      </p:nvGrpSpPr>
+      <p:grpSpPr>
+        <a:xfrm>
+          <a:off x="0" y="0"/>
+          <a:ext cx="0" cy="0"/>
+          <a:chOff x="0" y="0"/>
+          <a:chExt cx="0" cy="0"/>
+        </a:xfrm>
+      </p:grpSpPr>
+      <p:sp>
+        <p:nvSpPr>
+          <p:cNvPr id="2" name="HeaderBar"/>
+          <p:cNvSpPr/>
+          <p:nvPr/>
+        </p:nvSpPr>
+        <p:spPr>
+          <a:xfrm>
+            <a:off x="0" y="0"/>
+            <a:ext cx="9144000" cy="658368"/>
+          </a:xfrm>
+          <a:prstGeom prst="rect">
+            <a:avLst/>
+          </a:prstGeom>
+          <a:solidFill>
+            <a:srgbClr val="142238"/>
+          </a:solidFill>
+          <a:ln w="12700">
+            <a:solidFill>
+              <a:srgbClr val="142238"/>
+            </a:solidFill>
+            <a:prstDash val="solid"/>
+          </a:ln>
+        </p:spPr>
+      </p:sp>
+      <p:sp>
+        <p:nvSpPr>
+          <p:cNvPr id="3" name="GoldStrip"/>
+          <p:cNvSpPr/>
+          <p:nvPr/>
+        </p:nvSpPr>
+        <p:spPr>
+          <a:xfrm>
+            <a:off x="0" y="0"/>
+            <a:ext cx="54864" cy="658368"/>
+          </a:xfrm>
+          <a:prstGeom prst="rect">
+            <a:avLst/>
+          </a:prstGeom>
+          <a:solidFill>
+            <a:srgbClr val="C9A44B"/>
+          </a:solidFill>
+          <a:ln w="12700">
+            <a:solidFill>
+              <a:srgbClr val="C9A44B"/>
+            </a:solidFill>
+            <a:prstDash val="solid"/>
+          </a:ln>
+        </p:spPr>
+      </p:sp>
+      <p:sp>
+        <p:nvSpPr>
+          <p:cNvPr id="4" name="HeaderLeft"/>
+          <p:cNvSpPr/>
+          <p:nvPr/>
+        </p:nvSpPr>
+        <p:spPr>
+          <a:xfrm>
+            <a:off x="164592" y="0"/>
+            <a:ext cx="5486400" cy="658368"/>
+          </a:xfrm>
+          <a:prstGeom prst="rect">
+            <a:avLst/>
+          </a:prstGeom>
+          <a:noFill/>
+          <a:ln/>
+        </p:spPr>
+        <p:txBody>
+          <a:bodyPr wrap="square" lIns="0" tIns="0" rIns="0" bIns="0" rtlCol="0" anchor="ctr"/>
+          <a:lstStyle/>
+          <a:p>
+            <a:pPr algn="l" indent="0" marL="0">
+              <a:buNone/>
+            </a:pPr>
+            <a:r>
+              <a:rPr lang="en-US" sz="900" spc="200" kern="0" dirty="0">
+                <a:solidFill>
+                  <a:srgbClr val="64748B"/>
+                </a:solidFill>
+                <a:latin typeface="Calibri" pitchFamily="34" charset="0"/>
+              </a:rPr>
+              <a:t>ABIVAX  ·  AUDIT COMMITTEE  ·  CONFIDENTIAL</a:t>
+            </a:r>
+          </a:p>
+        </p:txBody>
+      </p:sp>
+      <p:sp>
+        <p:nvSpPr>
+          <p:cNvPr id="5" name="HeaderRight"/>
+          <p:cNvSpPr/>
+          <p:nvPr/>
+        </p:nvSpPr>
+        <p:spPr>
+          <a:xfrm>
+            <a:off x="5486400" y="0"/>
+            <a:ext cx="3474720" cy="658368"/>
+          </a:xfrm>
+          <a:prstGeom prst="rect">
+            <a:avLst/>
+          </a:prstGeom>
+          <a:noFill/>
+          <a:ln/>
+        </p:spPr>
+        <p:txBody>
+          <a:bodyPr wrap="square" lIns="0" tIns="0" rIns="0" bIns="0" rtlCol="0" anchor="ctr"/>
+          <a:lstStyle/>
+          <a:p>
+            <a:pPr algn="r" indent="0" marL="0">
+              <a:buNone/>
+            </a:pPr>
+            <a:r>
+              <a:rPr lang="en-US" sz="900" dirty="0">
+                <a:solidFill>
+                  <a:srgbClr val="94A3B8"/>
+                </a:solidFill>
+                <a:latin typeface="Calibri" pitchFamily="34" charset="0"/>
+              </a:rPr>
+              <a:t>Overview · Slide 2 of 9</a:t>
+            </a:r>
+          </a:p>
+        </p:txBody>
+      </p:sp>
+      <p:sp>
+        <p:nvSpPr>
+          <p:cNvPr id="6" name="SlideTitle"/>
+          <p:cNvSpPr/>
+          <p:nvPr/>
+        </p:nvSpPr>
+        <p:spPr>
+          <a:xfrm>
+            <a:off x="457200" y="749808"/>
+            <a:ext cx="8229600" cy="548640"/>
+          </a:xfrm>
+          <a:prstGeom prst="rect">
+            <a:avLst/>
+          </a:prstGeom>
+          <a:noFill/>
+          <a:ln/>
+        </p:spPr>
+        <p:txBody>
+          <a:bodyPr wrap="square" lIns="0" tIns="0" rIns="0" bIns="0" rtlCol="0" anchor="ctr"/>
+          <a:lstStyle/>
+          <a:p>
+            <a:pPr algn="l" indent="0" marL="0">
+              <a:buNone/>
+            </a:pPr>
+            <a:r>
+              <a:rPr lang="en-US" sz="2200" b="1" dirty="0">
+                <a:solidFill>
+                  <a:srgbClr val="F1F5F9"/>
+                </a:solidFill>
+                <a:latin typeface="Georgia" pitchFamily="34" charset="0"/>
+              </a:rPr>
+              <a:t>ERP Program Overview</a:t>
+            </a:r>
+          </a:p>
+        </p:txBody>
+      </p:sp>
+      <p:sp>
+        <p:nvSpPr>
+          <p:cNvPr id="7" name="Subtitle"/>
+          <p:cNvSpPr/>
+          <p:nvPr/>
+        </p:nvSpPr>
+        <p:spPr>
+          <a:xfrm>
+            <a:off x="457200" y="1371600"/>
+            <a:ext cx="8229600" cy="256032"/>
+          </a:xfrm>
+          <a:prstGeom prst="rect">
+            <a:avLst/>
+          </a:prstGeom>
+          <a:noFill/>
+          <a:ln/>
+        </p:spPr>
+        <p:txBody>
+          <a:bodyPr wrap="square" lIns="0" tIns="0" rIns="0" bIns="0" rtlCol="0" anchor="ctr"/>
+          <a:lstStyle/>
+          <a:p>
+            <a:pPr algn="l" indent="0" marL="0">
+              <a:buNone/>
+            </a:pPr>
+            <a:r>
+              <a:rPr lang="en-US" sz="1100" dirty="0">
+                <a:solidFill>
+                  <a:srgbClr val="94A3B8"/>
+                </a:solidFill>
+                <a:latin typeface="Calibri" pitchFamily="34" charset="0"/>
+              </a:rPr>
+              <a:t>NetSuite selected February 26, 2026 over SAP. Contract execution underway. Program mobilizes April 2026; go-live January 1, 2027.</a:t>
+            </a:r>
+          </a:p>
+        </p:txBody>
+      </p:sp>
+      <p:sp>
+        <p:nvSpPr>
+          <p:cNvPr id="8" name="Card1BG"/>
+          <p:cNvSpPr/>
+          <p:nvPr/>
+        </p:nvSpPr>
+        <p:spPr>
+          <a:xfrm>
+            <a:off x="457200" y="1737360"/>
+            <a:ext cx="2590000" cy="2800000"/>
+          </a:xfrm>
+          <a:prstGeom prst="rect">
+            <a:avLst/>
+          </a:prstGeom>
+          <a:solidFill>
+            <a:srgbClr val="0E1E38"/>
+          </a:solidFill>
+          <a:ln w="12700">
+            <a:solidFill>
+              <a:srgbClr val="1E3560"/>
+            </a:solidFill>
+            <a:prstDash val="solid"/>
+          </a:ln>
+          <a:effectLst>
+            <a:outerShdw sx="100000" sy="100000" kx="0" ky="0" algn="bl" rotWithShape="0" blurRad="127000" dist="38100" dir="8100000">
+              <a:srgbClr val="000000">
+                <a:alpha val="30000"/>
+              </a:srgbClr>
+            </a:outerShdw>
+          </a:effectLst>
+        </p:spPr>
+      </p:sp>
+      <p:sp>
+        <p:nvSpPr>
+          <p:cNvPr id="9" name="Card1Accent"/>
+          <p:cNvSpPr/>
+          <p:nvPr/>
+        </p:nvSpPr>
+        <p:spPr>
+          <a:xfrm>
+            <a:off x="457200" y="1737360"/>
+            <a:ext cx="50292" cy="2800000"/>
+          </a:xfrm>
+          <a:prstGeom prst="rect">
+            <a:avLst/>
+          </a:prstGeom>
+          <a:solidFill>
+            <a:srgbClr val="38BDF8"/>
+          </a:solidFill>
+          <a:ln w="12700">
+            <a:solidFill>
+              <a:srgbClr val="38BDF8"/>
+            </a:solidFill>
+            <a:prstDash val="solid"/>
+          </a:ln>
+        </p:spPr>
+      </p:sp>
+      <p:sp>
+        <p:nvSpPr>
+          <p:cNvPr id="10" name="Card1Num"/>
+          <p:cNvSpPr/>
+          <p:nvPr/>
+        </p:nvSpPr>
+        <p:spPr>
+          <a:xfrm>
+            <a:off x="612648" y="1810512"/>
+            <a:ext cx="347472" cy="310896"/>
+          </a:xfrm>
+          <a:prstGeom prst="rect">
+            <a:avLst/>
+          </a:prstGeom>
+          <a:noFill/>
+          <a:ln/>
+        </p:spPr>
+        <p:txBody>
+          <a:bodyPr wrap="square" lIns="0" tIns="0" rIns="0" bIns="0" rtlCol="0" anchor="ctr"/>
+          <a:lstStyle/>
+          <a:p>
+            <a:pPr algn="l" indent="0" marL="0">
+              <a:buNone/>
+            </a:pPr>
+            <a:r>
+              <a:rPr lang="en-US" sz="1800" b="1" dirty="0">
+                <a:solidFill>
+                  <a:srgbClr val="38BDF8"/>
+                </a:solidFill>
+                <a:latin typeface="Georgia" pitchFamily="34" charset="0"/>
+              </a:rPr>
+              <a:t>01</a:t>
+            </a:r>
+          </a:p>
+        </p:txBody>
+      </p:sp>
+      <p:sp>
+        <p:nvSpPr>
+          <p:cNvPr id="11" name="Card1Title"/>
+          <p:cNvSpPr/>
+          <p:nvPr/>
+        </p:nvSpPr>
+        <p:spPr>
+          <a:xfrm>
+            <a:off x="1005840" y="1810512"/>
+            <a:ext cx="1900000" cy="310896"/>
+          </a:xfrm>
+          <a:prstGeom prst="rect">
+            <a:avLst/>
+          </a:prstGeom>
+          <a:noFill/>
+          <a:ln/>
+        </p:spPr>
+        <p:txBody>
+          <a:bodyPr wrap="square" lIns="0" tIns="0" rIns="0" bIns="0" rtlCol="0" anchor="ctr"/>
+          <a:lstStyle/>
+          <a:p>
+            <a:pPr algn="l" indent="0" marL="0">
+              <a:buNone/>
+            </a:pPr>
+            <a:r>
+              <a:rPr lang="en-US" sz="1100" b="1" dirty="0">
+                <a:solidFill>
+                  <a:srgbClr val="F1F5F9"/>
+                </a:solidFill>
+                <a:latin typeface="Calibri" pitchFamily="34" charset="0"/>
+              </a:rPr>
+              <a:t>Vendor Selection</a:t>
+            </a:r>
+          </a:p>
+        </p:txBody>
+      </p:sp>
+      <p:sp>
+        <p:nvSpPr>
+          <p:cNvPr id="12" name="Card1Div"/>
+          <p:cNvSpPr/>
+          <p:nvPr/>
+        </p:nvSpPr>
+        <p:spPr>
+          <a:xfrm>
+            <a:off x="612648" y="2157984"/>
+            <a:ext cx="2300000" cy="9144"/>
+          </a:xfrm>
+          <a:prstGeom prst="rect">
+            <a:avLst/>
+          </a:prstGeom>
+          <a:solidFill>
+            <a:srgbClr val="1C3158"/>
+          </a:solidFill>
+          <a:ln w="12700">
+            <a:solidFill>
+              <a:srgbClr val="1C3158"/>
+            </a:solidFill>
+            <a:prstDash val="solid"/>
+          </a:ln>
+        </p:spPr>
+      </p:sp>
+      <p:sp>
+        <p:nvSpPr>
+          <p:cNvPr id="13" name="Card1Body"/>
+          <p:cNvSpPr/>
+          <p:nvPr/>
+        </p:nvSpPr>
+        <p:spPr>
+          <a:xfrm>
+            <a:off x="612648" y="2212848"/>
+            <a:ext cx="2300000" cy="2200000"/>
+          </a:xfrm>
+          <a:prstGeom prst="rect">
+            <a:avLst/>
+          </a:prstGeom>
+          <a:noFill/>
+          <a:ln/>
+        </p:spPr>
+        <p:txBody>
+          <a:bodyPr wrap="square" lIns="0" tIns="0" rIns="0" bIns="0" rtlCol="0" anchor="t"/>
+          <a:lstStyle/>
+          <a:p>
+            <a:pPr algn="l" indent="0" marL="0">
+              <a:buNone/>
+            </a:pPr>
+            <a:r>
+              <a:rPr lang="en-US" sz="1000" dirty="0">
+                <a:solidFill>
+                  <a:srgbClr val="94A3B8"/>
+                </a:solidFill>
+                <a:latin typeface="Calibri" pitchFamily="34" charset="0"/>
+              </a:rPr>
+              <a:t>NetSuite selected over SAP on February 26, 2026. Key factors: implementation speed (9 months vs. 18+), SaaS-native architecture, proven biotech install base, and total cost advantage. Contract execution underway with prep start targeted March 15, 2026.</a:t>
+            </a:r>
+          </a:p>
+        </p:txBody>
+      </p:sp>
+      <p:sp>
+        <p:nvSpPr>
+          <p:cNvPr id="14" name="Card2BG"/>
+          <p:cNvSpPr/>
+          <p:nvPr/>
+        </p:nvSpPr>
+        <p:spPr>
+          <a:xfrm>
+            <a:off x="3261800" y="1737360"/>
+            <a:ext cx="2590000" cy="2800000"/>
+          </a:xfrm>
+          <a:prstGeom prst="rect">
+            <a:avLst/>
+          </a:prstGeom>
+          <a:solidFill>
+            <a:srgbClr val="0E1E38"/>
+          </a:solidFill>
+          <a:ln w="12700">
+            <a:solidFill>
+              <a:srgbClr val="1E3560"/>
+            </a:solidFill>
+            <a:prstDash val="solid"/>
+          </a:ln>
+          <a:effectLst>
+            <a:outerShdw sx="100000" sy="100000" kx="0" ky="0" algn="bl" rotWithShape="0" blurRad="127000" dist="38100" dir="8100000">
+              <a:srgbClr val="000000">
+                <a:alpha val="30000"/>
+              </a:srgbClr>
+            </a:outerShdw>
+          </a:effectLst>
+        </p:spPr>
+      </p:sp>
+      <p:sp>
+        <p:nvSpPr>
+          <p:cNvPr id="15" name="Card2Accent"/>
+          <p:cNvSpPr/>
+          <p:nvPr/>
+        </p:nvSpPr>
+        <p:spPr>
+          <a:xfrm>
+            <a:off x="3261800" y="1737360"/>
+            <a:ext cx="50292" cy="2800000"/>
+          </a:xfrm>
+          <a:prstGeom prst="rect">
+            <a:avLst/>
+          </a:prstGeom>
+          <a:solidFill>
+            <a:srgbClr val="C9A44B"/>
+          </a:solidFill>
+          <a:ln w="12700">
+            <a:solidFill>
+              <a:srgbClr val="C9A44B"/>
+            </a:solidFill>
+            <a:prstDash val="solid"/>
+          </a:ln>
+        </p:spPr>
+      </p:sp>
+      <p:sp>
+        <p:nvSpPr>
+          <p:cNvPr id="16" name="Card2Num"/>
+          <p:cNvSpPr/>
+          <p:nvPr/>
+        </p:nvSpPr>
+        <p:spPr>
+          <a:xfrm>
+            <a:off x="3417248" y="1810512"/>
+            <a:ext cx="347472" cy="310896"/>
+          </a:xfrm>
+          <a:prstGeom prst="rect">
+            <a:avLst/>
+          </a:prstGeom>
+          <a:noFill/>
+          <a:ln/>
+        </p:spPr>
+        <p:txBody>
+          <a:bodyPr wrap="square" lIns="0" tIns="0" rIns="0" bIns="0" rtlCol="0" anchor="ctr"/>
+          <a:lstStyle/>
+          <a:p>
+            <a:pPr algn="l" indent="0" marL="0">
+              <a:buNone/>
+            </a:pPr>
+            <a:r>
+              <a:rPr lang="en-US" sz="1800" b="1" dirty="0">
+                <a:solidFill>
+                  <a:srgbClr val="C9A44B"/>
+                </a:solidFill>
+                <a:latin typeface="Georgia" pitchFamily="34" charset="0"/>
+              </a:rPr>
+              <a:t>02</a:t>
+            </a:r>
+          </a:p>
+        </p:txBody>
+      </p:sp>
+      <p:sp>
+        <p:nvSpPr>
+          <p:cNvPr id="17" name="Card2Title"/>
+          <p:cNvSpPr/>
+          <p:nvPr/>
+        </p:nvSpPr>
+        <p:spPr>
+          <a:xfrm>
+            <a:off x="3810440" y="1810512"/>
+            <a:ext cx="1900000" cy="310896"/>
+          </a:xfrm>
+          <a:prstGeom prst="rect">
+            <a:avLst/>
+          </a:prstGeom>
+          <a:noFill/>
+          <a:ln/>
+        </p:spPr>
+        <p:txBody>
+          <a:bodyPr wrap="square" lIns="0" tIns="0" rIns="0" bIns="0" rtlCol="0" anchor="ctr"/>
+          <a:lstStyle/>
+          <a:p>
+            <a:pPr algn="l" indent="0" marL="0">
+              <a:buNone/>
+            </a:pPr>
+            <a:r>
+              <a:rPr lang="en-US" sz="1100" b="1" dirty="0">
+                <a:solidFill>
+                  <a:srgbClr val="F1F5F9"/>
+                </a:solidFill>
+                <a:latin typeface="Calibri" pitchFamily="34" charset="0"/>
+              </a:rPr>
+              <a:t>Implementation Path</a:t>
+            </a:r>
+          </a:p>
+        </p:txBody>
+      </p:sp>
+      <p:sp>
+        <p:nvSpPr>
+          <p:cNvPr id="18" name="Card2Div"/>
+          <p:cNvSpPr/>
+          <p:nvPr/>
+        </p:nvSpPr>
+        <p:spPr>
+          <a:xfrm>
+            <a:off x="3417248" y="2157984"/>
+            <a:ext cx="2300000" cy="9144"/>
+          </a:xfrm>
+          <a:prstGeom prst="rect">
+            <a:avLst/>
+          </a:prstGeom>
+          <a:solidFill>
+            <a:srgbClr val="1C3158"/>
+          </a:solidFill>
+          <a:ln w="12700">
+            <a:solidFill>
+              <a:srgbClr val="1C3158"/>
+            </a:solidFill>
+            <a:prstDash val="solid"/>
+          </a:ln>
+        </p:spPr>
+      </p:sp>
+      <p:sp>
+        <p:nvSpPr>
+          <p:cNvPr id="19" name="Card2Body"/>
+          <p:cNvSpPr/>
+          <p:nvPr/>
+        </p:nvSpPr>
+        <p:spPr>
+          <a:xfrm>
+            <a:off x="3417248" y="2212848"/>
+            <a:ext cx="2300000" cy="2200000"/>
+          </a:xfrm>
+          <a:prstGeom prst="rect">
+            <a:avLst/>
+          </a:prstGeom>
+          <a:noFill/>
+          <a:ln/>
+        </p:spPr>
+        <p:txBody>
+          <a:bodyPr wrap="square" lIns="0" tIns="0" rIns="0" bIns="0" rtlCol="0" anchor="t"/>
+          <a:lstStyle/>
+          <a:p>
+            <a:pPr algn="l" indent="0" marL="0">
+              <a:buNone/>
+            </a:pPr>
+            <a:r>
+              <a:rPr lang="en-US" sz="1000" dirty="0">
+                <a:solidFill>
+                  <a:srgbClr val="94A3B8"/>
+                </a:solidFill>
+                <a:latin typeface="Calibri" pitchFamily="34" charset="0"/>
+              </a:rPr>
+              <a:t>Apr 2026: Mobilization — team, blueprint prep, data planning. Apr–Nov 2026: Configure, walkthrough rounds, data migration, integrations, UAT across US and France. Dec 27, 2026: Go-live. Non-negotiable — tied to US public launch Dec 2027.</a:t>
+            </a:r>
+          </a:p>
+        </p:txBody>
+      </p:sp>
+      <p:sp>
+        <p:nvSpPr>
+          <p:cNvPr id="20" name="Card3BG"/>
+          <p:cNvSpPr/>
+          <p:nvPr/>
+        </p:nvSpPr>
+        <p:spPr>
+          <a:xfrm>
+            <a:off x="6066400" y="1737360"/>
+            <a:ext cx="2590000" cy="2800000"/>
+          </a:xfrm>
+          <a:prstGeom prst="rect">
+            <a:avLst/>
+          </a:prstGeom>
+          <a:solidFill>
+            <a:srgbClr val="0E1E38"/>
+          </a:solidFill>
+          <a:ln w="12700">
+            <a:solidFill>
+              <a:srgbClr val="1E3560"/>
+            </a:solidFill>
+            <a:prstDash val="solid"/>
+          </a:ln>
+          <a:effectLst>
+            <a:outerShdw sx="100000" sy="100000" kx="0" ky="0" algn="bl" rotWithShape="0" blurRad="127000" dist="38100" dir="8100000">
+              <a:srgbClr val="000000">
+                <a:alpha val="30000"/>
+              </a:srgbClr>
+            </a:outerShdw>
+          </a:effectLst>
+        </p:spPr>
+      </p:sp>
+      <p:sp>
+        <p:nvSpPr>
+          <p:cNvPr id="21" name="Card3Accent"/>
+          <p:cNvSpPr/>
+          <p:nvPr/>
+        </p:nvSpPr>
+        <p:spPr>
+          <a:xfrm>
+            <a:off x="6066400" y="1737360"/>
+            <a:ext cx="50292" cy="2800000"/>
+          </a:xfrm>
+          <a:prstGeom prst="rect">
+            <a:avLst/>
+          </a:prstGeom>
+          <a:solidFill>
+            <a:srgbClr val="10B981"/>
+          </a:solidFill>
+          <a:ln w="12700">
+            <a:solidFill>
+              <a:srgbClr val="10B981"/>
+            </a:solidFill>
+            <a:prstDash val="solid"/>
+          </a:ln>
+        </p:spPr>
+      </p:sp>
+      <p:sp>
+        <p:nvSpPr>
+          <p:cNvPr id="22" name="Card3Num"/>
+          <p:cNvSpPr/>
+          <p:nvPr/>
+        </p:nvSpPr>
+        <p:spPr>
+          <a:xfrm>
+            <a:off x="6221848" y="1810512"/>
+            <a:ext cx="347472" cy="310896"/>
+          </a:xfrm>
+          <a:prstGeom prst="rect">
+            <a:avLst/>
+          </a:prstGeom>
+          <a:noFill/>
+          <a:ln/>
+        </p:spPr>
+        <p:txBody>
+          <a:bodyPr wrap="square" lIns="0" tIns="0" rIns="0" bIns="0" rtlCol="0" anchor="ctr"/>
+          <a:lstStyle/>
+          <a:p>
+            <a:pPr algn="l" indent="0" marL="0">
+              <a:buNone/>
+            </a:pPr>
+            <a:r>
+              <a:rPr lang="en-US" sz="1800" b="1" dirty="0">
+                <a:solidFill>
+                  <a:srgbClr val="10B981"/>
+                </a:solidFill>
+                <a:latin typeface="Georgia" pitchFamily="34" charset="0"/>
+              </a:rPr>
+              <a:t>03</a:t>
+            </a:r>
+          </a:p>
+        </p:txBody>
+      </p:sp>
+      <p:sp>
+        <p:nvSpPr>
+          <p:cNvPr id="23" name="Card3Title"/>
+          <p:cNvSpPr/>
+          <p:nvPr/>
+        </p:nvSpPr>
+        <p:spPr>
+          <a:xfrm>
+            <a:off x="6614840" y="1810512"/>
+            <a:ext cx="1900000" cy="310896"/>
+          </a:xfrm>
+          <a:prstGeom prst="rect">
+            <a:avLst/>
+          </a:prstGeom>
+          <a:noFill/>
+          <a:ln/>
+        </p:spPr>
+        <p:txBody>
+          <a:bodyPr wrap="square" lIns="0" tIns="0" rIns="0" bIns="0" rtlCol="0" anchor="ctr"/>
+          <a:lstStyle/>
+          <a:p>
+            <a:pPr algn="l" indent="0" marL="0">
+              <a:buNone/>
+            </a:pPr>
+            <a:r>
+              <a:rPr lang="en-US" sz="1100" b="1" dirty="0">
+                <a:solidFill>
+                  <a:srgbClr val="F1F5F9"/>
+                </a:solidFill>
+                <a:latin typeface="Calibri" pitchFamily="34" charset="0"/>
+              </a:rPr>
+              <a:t>Strategic Purpose</a:t>
+            </a:r>
+          </a:p>
+        </p:txBody>
+      </p:sp>
+      <p:sp>
+        <p:nvSpPr>
+          <p:cNvPr id="24" name="Card3Div"/>
+          <p:cNvSpPr/>
+          <p:nvPr/>
+        </p:nvSpPr>
+        <p:spPr>
+          <a:xfrm>
+            <a:off x="6221848" y="2157984"/>
+            <a:ext cx="2300000" cy="9144"/>
+          </a:xfrm>
+          <a:prstGeom prst="rect">
+            <a:avLst/>
+          </a:prstGeom>
+          <a:solidFill>
+            <a:srgbClr val="1C3158"/>
+          </a:solidFill>
+          <a:ln w="12700">
+            <a:solidFill>
+              <a:srgbClr val="1C3158"/>
+            </a:solidFill>
+            <a:prstDash val="solid"/>
+          </a:ln>
+        </p:spPr>
+      </p:sp>
+      <p:sp>
+        <p:nvSpPr>
+          <p:cNvPr id="25" name="Card3Body"/>
+          <p:cNvSpPr/>
+          <p:nvPr/>
+        </p:nvSpPr>
+        <p:spPr>
+          <a:xfrm>
+            <a:off x="6221848" y="2212848"/>
+            <a:ext cx="2300000" cy="2200000"/>
+          </a:xfrm>
+          <a:prstGeom prst="rect">
+            <a:avLst/>
+          </a:prstGeom>
+          <a:noFill/>
+          <a:ln/>
+        </p:spPr>
+        <p:txBody>
+          <a:bodyPr wrap="square" lIns="0" tIns="0" rIns="0" bIns="0" rtlCol="0" anchor="t"/>
+          <a:lstStyle/>
+          <a:p>
+            <a:pPr algn="l" indent="0" marL="0">
+              <a:buNone/>
+            </a:pPr>
+            <a:r>
+              <a:rPr lang="en-US" sz="1000" dirty="0">
+                <a:solidFill>
+                  <a:srgbClr val="94A3B8"/>
+                </a:solidFill>
+                <a:latin typeface="Calibri" pitchFamily="34" charset="0"/>
+              </a:rPr>
+              <a:t>This program is primarily a SOX control-remediation program. NetSuite replaces fragmented manual processes with system-enforced controls across P2P, Audit/Reporting, and period close. Automation efficiency is a Phase 2 objective — after January 1, 2027 go-live.</a:t>
+            </a:r>
+          </a:p>
+        </p:txBody>
+      </p:sp>
+      <p:sp>
+        <p:nvSpPr>
+          <p:cNvPr id="26" name="FooterBar"/>
+          <p:cNvSpPr/>
+          <p:nvPr/>
+        </p:nvSpPr>
+        <p:spPr>
+          <a:xfrm>
+            <a:off x="0" y="4846320"/>
+            <a:ext cx="9144000" cy="297180"/>
+          </a:xfrm>
+          <a:prstGeom prst="rect">
+            <a:avLst/>
+          </a:prstGeom>
+          <a:solidFill>
+            <a:srgbClr val="142238"/>
+          </a:solidFill>
+          <a:ln w="12700">
+            <a:solidFill>
+              <a:srgbClr val="142238"/>
+            </a:solidFill>
+            <a:prstDash val="solid"/>
+          </a:ln>
+        </p:spPr>
+      </p:sp>
+      <p:sp>
+        <p:nvSpPr>
+          <p:cNvPr id="27" name="FooterPageNum"/>
+          <p:cNvSpPr/>
+          <p:nvPr/>
+        </p:nvSpPr>
+        <p:spPr>
+          <a:xfrm>
+            <a:off x="0" y="4846320"/>
+            <a:ext cx="8869680" cy="297180"/>
+          </a:xfrm>
+          <a:prstGeom prst="rect">
+            <a:avLst/>
+          </a:prstGeom>
+          <a:noFill/>
+          <a:ln/>
+        </p:spPr>
+        <p:txBody>
+          <a:bodyPr wrap="square" lIns="0" tIns="0" rIns="0" bIns="0" rtlCol="0" anchor="ctr"/>
+          <a:lstStyle/>
+          <a:p>
+            <a:pPr algn="r" indent="0" marL="0">
+              <a:buNone/>
+            </a:pPr>
+            <a:r>
+              <a:rPr lang="en-US" sz="900" dirty="0">
+                <a:solidFill>
+                  <a:srgbClr val="64748B"/>
+                </a:solidFill>
+                <a:latin typeface="Calibri" pitchFamily="34" charset="0"/>
+              </a:rPr>
+              <a:t>2 / 9</a:t>
+            </a:r>
+          </a:p>
+        </p:txBody>
+      </p:sp>
+      <p:sp>
+        <p:nvSpPr>
+          <p:cNvPr id="28" name="FooterLabel"/>
+          <p:cNvSpPr/>
+          <p:nvPr/>
+        </p:nvSpPr>
+        <p:spPr>
+          <a:xfrm>
+            <a:off x="274320" y="4846320"/>
+            <a:ext cx="5486400" cy="297180"/>
+          </a:xfrm>
+          <a:prstGeom prst="rect">
+            <a:avLst/>
+          </a:prstGeom>
+          <a:noFill/>
+          <a:ln/>
+        </p:spPr>
+        <p:txBody>
+          <a:bodyPr wrap="square" lIns="0" tIns="0" rIns="0" bIns="0" rtlCol="0" anchor="ctr"/>
+          <a:lstStyle/>
+          <a:p>
+            <a:pPr algn="l" indent="0" marL="0">
+              <a:buNone/>
+            </a:pPr>
+            <a:r>
+              <a:rPr lang="en-US" sz="900" dirty="0">
+                <a:solidFill>
+                  <a:srgbClr val="64748B"/>
+                </a:solidFill>
+                <a:latin typeface="Calibri" pitchFamily="34" charset="0"/>
+              </a:rPr>
+              <a:t>Audit Committee ERP Controls Readout  ·  March 2026</a:t>
+            </a:r>
+          </a:p>
+        </p:txBody>
+      </p:sp>
+    </p:spTree>
+  </p:cSld>
+  <p:clrMapOvr>
+    <a:masterClrMapping/>
+  </p:clrMapOvr>
+</p:sld>
+</file>
+
+<file path=ppt/slides/slide8.xml><?xml version="1.0" encoding="utf-8"?>
+<p:sld xmlns:a="http://schemas.openxmlformats.org/drawingml/2006/main" xmlns:r="http://schemas.openxmlformats.org/officeDocument/2006/relationships" xmlns:p="http://schemas.openxmlformats.org/presentationml/2006/main">
+  <p:cSld name="Implementation Timeline">
+    <p:bg>
+      <p:bgPr>
+        <a:solidFill>
+          <a:srgbClr val="080E1C"/>
+        </a:solidFill>
+      </p:bgPr>
+    </p:bg>
+    <p:spTree>
+      <p:nvGrpSpPr>
+        <p:cNvPr id="1" name=""/>
+        <p:cNvGrpSpPr/>
+        <p:nvPr/>
+      </p:nvGrpSpPr>
+      <p:grpSpPr>
+        <a:xfrm>
+          <a:off x="0" y="0"/>
+          <a:ext cx="0" cy="0"/>
+          <a:chOff x="0" y="0"/>
+          <a:chExt cx="0" cy="0"/>
+        </a:xfrm>
+      </p:grpSpPr>
+      <p:sp>
+        <p:nvSpPr>
+          <p:cNvPr id="2" name="HeaderBar"/>
+          <p:cNvSpPr/>
+          <p:nvPr/>
+        </p:nvSpPr>
+        <p:spPr>
+          <a:xfrm>
+            <a:off x="0" y="0"/>
+            <a:ext cx="9144000" cy="658368"/>
+          </a:xfrm>
+          <a:prstGeom prst="rect">
+            <a:avLst/>
+          </a:prstGeom>
+          <a:solidFill>
+            <a:srgbClr val="142238"/>
+          </a:solidFill>
+          <a:ln w="12700">
+            <a:solidFill>
+              <a:srgbClr val="142238"/>
+            </a:solidFill>
+            <a:prstDash val="solid"/>
+          </a:ln>
+        </p:spPr>
+      </p:sp>
+      <p:sp>
+        <p:nvSpPr>
+          <p:cNvPr id="3" name="GoldStrip"/>
+          <p:cNvSpPr/>
+          <p:nvPr/>
+        </p:nvSpPr>
+        <p:spPr>
+          <a:xfrm>
+            <a:off x="0" y="0"/>
+            <a:ext cx="54864" cy="658368"/>
+          </a:xfrm>
+          <a:prstGeom prst="rect">
+            <a:avLst/>
+          </a:prstGeom>
+          <a:solidFill>
+            <a:srgbClr val="C9A44B"/>
+          </a:solidFill>
+          <a:ln w="12700">
+            <a:solidFill>
+              <a:srgbClr val="C9A44B"/>
+            </a:solidFill>
+            <a:prstDash val="solid"/>
+          </a:ln>
+        </p:spPr>
+      </p:sp>
+      <p:sp>
+        <p:nvSpPr>
+          <p:cNvPr id="4" name="HeaderLeft"/>
+          <p:cNvSpPr/>
+          <p:nvPr/>
+        </p:nvSpPr>
+        <p:spPr>
+          <a:xfrm>
+            <a:off x="164592" y="0"/>
+            <a:ext cx="5486400" cy="658368"/>
+          </a:xfrm>
+          <a:prstGeom prst="rect">
+            <a:avLst/>
+          </a:prstGeom>
+          <a:noFill/>
+          <a:ln/>
+        </p:spPr>
+        <p:txBody>
+          <a:bodyPr wrap="square" lIns="0" tIns="0" rIns="0" bIns="0" rtlCol="0" anchor="ctr"/>
+          <a:lstStyle/>
+          <a:p>
+            <a:pPr algn="l" indent="0" marL="0">
+              <a:buNone/>
+            </a:pPr>
+            <a:r>
+              <a:rPr lang="en-US" sz="900" spc="200" kern="0" dirty="0">
+                <a:solidFill>
+                  <a:srgbClr val="64748B"/>
+                </a:solidFill>
+                <a:latin typeface="Calibri" pitchFamily="34" charset="0"/>
+              </a:rPr>
+              <a:t>ABIVAX  ·  AUDIT COMMITTEE  ·  CONFIDENTIAL</a:t>
+            </a:r>
+          </a:p>
+        </p:txBody>
+      </p:sp>
+      <p:sp>
+        <p:nvSpPr>
+          <p:cNvPr id="5" name="HeaderRight"/>
+          <p:cNvSpPr/>
+          <p:nvPr/>
+        </p:nvSpPr>
+        <p:spPr>
+          <a:xfrm>
+            <a:off x="5486400" y="0"/>
+            <a:ext cx="3474720" cy="658368"/>
+          </a:xfrm>
+          <a:prstGeom prst="rect">
+            <a:avLst/>
+          </a:prstGeom>
+          <a:noFill/>
+          <a:ln/>
+        </p:spPr>
+        <p:txBody>
+          <a:bodyPr wrap="square" lIns="0" tIns="0" rIns="0" bIns="0" rtlCol="0" anchor="ctr"/>
+          <a:lstStyle/>
+          <a:p>
+            <a:pPr algn="r" indent="0" marL="0">
+              <a:buNone/>
+            </a:pPr>
+            <a:r>
+              <a:rPr lang="en-US" sz="900" dirty="0">
+                <a:solidFill>
+                  <a:srgbClr val="94A3B8"/>
+                </a:solidFill>
+                <a:latin typeface="Calibri" pitchFamily="34" charset="0"/>
+              </a:rPr>
+              <a:t>Timeline · Slide 3 of 9</a:t>
+            </a:r>
+          </a:p>
+        </p:txBody>
+      </p:sp>
+      <p:sp>
+        <p:nvSpPr>
+          <p:cNvPr id="6" name="SlideTitle"/>
+          <p:cNvSpPr/>
+          <p:nvPr/>
+        </p:nvSpPr>
+        <p:spPr>
+          <a:xfrm>
+            <a:off x="457200" y="749808"/>
+            <a:ext cx="8229600" cy="548640"/>
+          </a:xfrm>
+          <a:prstGeom prst="rect">
+            <a:avLst/>
+          </a:prstGeom>
+          <a:noFill/>
+          <a:ln/>
+        </p:spPr>
+        <p:txBody>
+          <a:bodyPr wrap="square" lIns="0" tIns="0" rIns="0" bIns="0" rtlCol="0" anchor="ctr"/>
+          <a:lstStyle/>
+          <a:p>
+            <a:pPr algn="l" indent="0" marL="0">
+              <a:buNone/>
+            </a:pPr>
+            <a:r>
+              <a:rPr lang="en-US" sz="2200" b="1" dirty="0">
+                <a:solidFill>
+                  <a:srgbClr val="F1F5F9"/>
+                </a:solidFill>
+                <a:latin typeface="Georgia" pitchFamily="34" charset="0"/>
+              </a:rPr>
+              <a:t>Implementation Timeline</a:t>
+            </a:r>
+          </a:p>
+        </p:txBody>
+      </p:sp>
+      <p:sp>
+        <p:nvSpPr>
+          <p:cNvPr id="7" name="Subtitle"/>
+          <p:cNvSpPr/>
+          <p:nvPr/>
+        </p:nvSpPr>
+        <p:spPr>
+          <a:xfrm>
+            <a:off x="457200" y="1371600"/>
+            <a:ext cx="8229600" cy="256032"/>
+          </a:xfrm>
+          <a:prstGeom prst="rect">
+            <a:avLst/>
+          </a:prstGeom>
+          <a:noFill/>
+          <a:ln/>
+        </p:spPr>
+        <p:txBody>
+          <a:bodyPr wrap="square" lIns="0" tIns="0" rIns="0" bIns="0" rtlCol="0" anchor="ctr"/>
+          <a:lstStyle/>
+          <a:p>
+            <a:pPr algn="l" indent="0" marL="0">
+              <a:buNone/>
+            </a:pPr>
+            <a:r>
+              <a:rPr lang="en-US" sz="1100" dirty="0">
+                <a:solidFill>
+                  <a:srgbClr val="94A3B8"/>
+                </a:solidFill>
+                <a:latin typeface="Calibri" pitchFamily="34" charset="0"/>
+              </a:rPr>
+              <a:t>NetSuite implementation: March 15, 2026 prep start → December 27, 2026 go-live → January 17, 2027 post-support complete</a:t>
+            </a:r>
+          </a:p>
+        </p:txBody>
+      </p:sp>
+      <p:sp>
+        <p:nvSpPr>
+          <p:cNvPr id="8" name="Phase1Box"/>
+          <p:cNvSpPr/>
+          <p:nvPr/>
+        </p:nvSpPr>
+        <p:spPr>
+          <a:xfrm>
+            <a:off x="457200" y="1750000"/>
+            <a:ext cx="1500000" cy="700000"/>
+          </a:xfrm>
+          <a:prstGeom prst="rect">
+            <a:avLst/>
+          </a:prstGeom>
+          <a:solidFill>
+            <a:srgbClr val="0E2040"/>
+          </a:solidFill>
+          <a:ln w="19050">
+            <a:solidFill>
+              <a:srgbClr val="38BDF8"/>
+            </a:solidFill>
+            <a:prstDash val="solid"/>
+          </a:ln>
+        </p:spPr>
+      </p:sp>
+      <p:sp>
+        <p:nvSpPr>
+          <p:cNvPr id="9" name="Phase1Label"/>
+          <p:cNvSpPr/>
+          <p:nvPr/>
+        </p:nvSpPr>
+        <p:spPr>
+          <a:xfrm>
+            <a:off x="457200" y="1750000"/>
+            <a:ext cx="1500000" cy="700000"/>
+          </a:xfrm>
+          <a:prstGeom prst="rect">
+            <a:avLst/>
+          </a:prstGeom>
+          <a:noFill/>
+          <a:ln/>
+        </p:spPr>
+        <p:txBody>
+          <a:bodyPr wrap="square" lIns="91440" tIns="91440" rIns="91440" bIns="91440" rtlCol="0" anchor="ctr"/>
+          <a:lstStyle/>
+          <a:p>
+            <a:pPr algn="ctr" indent="0" marL="0">
+              <a:buNone/>
+            </a:pPr>
+            <a:r>
+              <a:rPr lang="en-US" sz="900" b="1" dirty="0">
+                <a:solidFill>
+                  <a:srgbClr val="38BDF8"/>
+                </a:solidFill>
+                <a:latin typeface="Calibri" pitchFamily="34" charset="0"/>
+              </a:rPr>
+              <a:t>Initiation &amp; Design</a:t>
+            </a:r>
+          </a:p>
+        </p:txBody>
+      </p:sp>
+      <p:sp>
+        <p:nvSpPr>
+          <p:cNvPr id="10" name="Phase2Box"/>
+          <p:cNvSpPr/>
+          <p:nvPr/>
+        </p:nvSpPr>
+        <p:spPr>
+          <a:xfrm>
+            <a:off x="2139600" y="1750000"/>
+            <a:ext cx="1820000" cy="700000"/>
+          </a:xfrm>
+          <a:prstGeom prst="rect">
+            <a:avLst/>
+          </a:prstGeom>
+          <a:solidFill>
+            <a:srgbClr val="1A1600"/>
+          </a:solidFill>
+          <a:ln w="19050">
+            <a:solidFill>
+              <a:srgbClr val="C9A44B"/>
+            </a:solidFill>
+            <a:prstDash val="solid"/>
+          </a:ln>
+        </p:spPr>
+      </p:sp>
+      <p:sp>
+        <p:nvSpPr>
+          <p:cNvPr id="11" name="Phase2Label"/>
+          <p:cNvSpPr/>
+          <p:nvPr/>
+        </p:nvSpPr>
+        <p:spPr>
+          <a:xfrm>
+            <a:off x="2139600" y="1750000"/>
+            <a:ext cx="1820000" cy="700000"/>
+          </a:xfrm>
+          <a:prstGeom prst="rect">
+            <a:avLst/>
+          </a:prstGeom>
+          <a:noFill/>
+          <a:ln/>
+        </p:spPr>
+        <p:txBody>
+          <a:bodyPr wrap="square" lIns="91440" tIns="91440" rIns="91440" bIns="91440" rtlCol="0" anchor="ctr"/>
+          <a:lstStyle/>
+          <a:p>
+            <a:pPr algn="ctr" indent="0" marL="0">
+              <a:buNone/>
+            </a:pPr>
+            <a:r>
+              <a:rPr lang="en-US" sz="900" b="1" dirty="0">
+                <a:solidFill>
+                  <a:srgbClr val="C9A44B"/>
+                </a:solidFill>
+                <a:latin typeface="Calibri" pitchFamily="34" charset="0"/>
+              </a:rPr>
+              <a:t>Configure &amp; Build</a:t>
+            </a:r>
+          </a:p>
+        </p:txBody>
+      </p:sp>
+      <p:sp>
+        <p:nvSpPr>
+          <p:cNvPr id="12" name="Phase3Box"/>
+          <p:cNvSpPr/>
+          <p:nvPr/>
+        </p:nvSpPr>
+        <p:spPr>
+          <a:xfrm>
+            <a:off x="4142000" y="1750000"/>
+            <a:ext cx="1480000" cy="700000"/>
+          </a:xfrm>
+          <a:prstGeom prst="rect">
+            <a:avLst/>
+          </a:prstGeom>
+          <a:solidFill>
+            <a:srgbClr val="001A0F"/>
+          </a:solidFill>
+          <a:ln w="19050">
+            <a:solidFill>
+              <a:srgbClr val="10B981"/>
+            </a:solidFill>
+            <a:prstDash val="solid"/>
+          </a:ln>
+        </p:spPr>
+      </p:sp>
+      <p:sp>
+        <p:nvSpPr>
+          <p:cNvPr id="13" name="Phase3Label"/>
+          <p:cNvSpPr/>
+          <p:nvPr/>
+        </p:nvSpPr>
+        <p:spPr>
+          <a:xfrm>
+            <a:off x="4142000" y="1750000"/>
+            <a:ext cx="1480000" cy="700000"/>
+          </a:xfrm>
+          <a:prstGeom prst="rect">
+            <a:avLst/>
+          </a:prstGeom>
+          <a:noFill/>
+          <a:ln/>
+        </p:spPr>
+        <p:txBody>
+          <a:bodyPr wrap="square" lIns="91440" tIns="91440" rIns="91440" bIns="91440" rtlCol="0" anchor="ctr"/>
+          <a:lstStyle/>
+          <a:p>
+            <a:pPr algn="ctr" indent="0" marL="0">
+              <a:buNone/>
+            </a:pPr>
+            <a:r>
+              <a:rPr lang="en-US" sz="900" b="1" dirty="0">
+                <a:solidFill>
+                  <a:srgbClr val="10B981"/>
+                </a:solidFill>
+                <a:latin typeface="Calibri" pitchFamily="34" charset="0"/>
+              </a:rPr>
+              <a:t>Test &amp; Validate</a:t>
+            </a:r>
+          </a:p>
+        </p:txBody>
+      </p:sp>
+      <p:sp>
+        <p:nvSpPr>
+          <p:cNvPr id="14" name="Phase4Box"/>
+          <p:cNvSpPr/>
+          <p:nvPr/>
+        </p:nvSpPr>
+        <p:spPr>
+          <a:xfrm>
+            <a:off x="5804400" y="1750000"/>
+            <a:ext cx="1480000" cy="700000"/>
+          </a:xfrm>
+          <a:prstGeom prst="rect">
+            <a:avLst/>
+          </a:prstGeom>
+          <a:solidFill>
+            <a:srgbClr val="1A0E00"/>
+          </a:solidFill>
+          <a:ln w="19050">
+            <a:solidFill>
+              <a:srgbClr val="F59E0B"/>
+            </a:solidFill>
+            <a:prstDash val="solid"/>
+          </a:ln>
+        </p:spPr>
+      </p:sp>
+      <p:sp>
+        <p:nvSpPr>
+          <p:cNvPr id="15" name="Phase4Label"/>
+          <p:cNvSpPr/>
+          <p:nvPr/>
+        </p:nvSpPr>
+        <p:spPr>
+          <a:xfrm>
+            <a:off x="5804400" y="1750000"/>
+            <a:ext cx="1480000" cy="700000"/>
+          </a:xfrm>
+          <a:prstGeom prst="rect">
+            <a:avLst/>
+          </a:prstGeom>
+          <a:noFill/>
+          <a:ln/>
+        </p:spPr>
+        <p:txBody>
+          <a:bodyPr wrap="square" lIns="91440" tIns="91440" rIns="91440" bIns="91440" rtlCol="0" anchor="ctr"/>
+          <a:lstStyle/>
+          <a:p>
+            <a:pPr algn="ctr" indent="0" marL="0">
+              <a:buNone/>
+            </a:pPr>
+            <a:r>
+              <a:rPr lang="en-US" sz="900" b="1" dirty="0">
+                <a:solidFill>
+                  <a:srgbClr val="F59E0B"/>
+                </a:solidFill>
+                <a:latin typeface="Calibri" pitchFamily="34" charset="0"/>
+              </a:rPr>
+              <a:t>Migration &amp; UAT</a:t>
+            </a:r>
+          </a:p>
+        </p:txBody>
+      </p:sp>
+      <p:sp>
+        <p:nvSpPr>
+          <p:cNvPr id="16" name="Phase5Box"/>
+          <p:cNvSpPr/>
+          <p:nvPr/>
+        </p:nvSpPr>
+        <p:spPr>
+          <a:xfrm>
+            <a:off x="7466800" y="1750000"/>
+            <a:ext cx="719800" cy="700000"/>
+          </a:xfrm>
+          <a:prstGeom prst="rect">
+            <a:avLst/>
+          </a:prstGeom>
+          <a:solidFill>
+            <a:srgbClr val="C9A44B"/>
+          </a:solidFill>
+          <a:ln w="12700">
+            <a:solidFill>
+              <a:srgbClr val="C9A44B"/>
+            </a:solidFill>
+            <a:prstDash val="solid"/>
+          </a:ln>
+        </p:spPr>
+      </p:sp>
+      <p:sp>
+        <p:nvSpPr>
+          <p:cNvPr id="17" name="Phase5Label"/>
+          <p:cNvSpPr/>
+          <p:nvPr/>
+        </p:nvSpPr>
+        <p:spPr>
+          <a:xfrm>
+            <a:off x="7466800" y="1750000"/>
+            <a:ext cx="719800" cy="700000"/>
+          </a:xfrm>
+          <a:prstGeom prst="rect">
+            <a:avLst/>
+          </a:prstGeom>
+          <a:noFill/>
+          <a:ln/>
+        </p:spPr>
+        <p:txBody>
+          <a:bodyPr wrap="square" lIns="45720" tIns="45720" rIns="45720" bIns="45720" rtlCol="0" anchor="ctr"/>
+          <a:lstStyle/>
+          <a:p>
+            <a:pPr algn="ctr" indent="0" marL="0">
+              <a:buNone/>
+            </a:pPr>
+            <a:r>
+              <a:rPr lang="en-US" sz="900" b="1" dirty="0">
+                <a:solidFill>
+                  <a:srgbClr val="080E1C"/>
+                </a:solidFill>
+                <a:latin typeface="Calibri" pitchFamily="34" charset="0"/>
+              </a:rPr>
+              <a:t>GO-LIVE</a:t>
+            </a:r>
+          </a:p>
+        </p:txBody>
+      </p:sp>
+      <p:sp>
+        <p:nvSpPr>
+          <p:cNvPr id="18" name="TimelineSpine"/>
+          <p:cNvSpPr/>
+          <p:nvPr/>
+        </p:nvSpPr>
+        <p:spPr>
+          <a:xfrm>
+            <a:off x="457200" y="2550000"/>
+            <a:ext cx="7729400" cy="54864"/>
+          </a:xfrm>
+          <a:prstGeom prst="rect">
+            <a:avLst/>
+          </a:prstGeom>
+          <a:solidFill>
+            <a:srgbClr val="1E3560"/>
+          </a:solidFill>
+          <a:ln w="12700">
+            <a:solidFill>
+              <a:srgbClr val="1E3560"/>
+            </a:solidFill>
+            <a:prstDash val="solid"/>
+          </a:ln>
+        </p:spPr>
+      </p:sp>
+      <p:sp>
+        <p:nvSpPr>
+          <p:cNvPr id="19" name="DateP1"/>
+          <p:cNvSpPr/>
+          <p:nvPr/>
+        </p:nvSpPr>
+        <p:spPr>
+          <a:xfrm>
+            <a:off x="457200" y="2650000"/>
+            <a:ext cx="1500000" cy="220000"/>
+          </a:xfrm>
+          <a:prstGeom prst="rect">
+            <a:avLst/>
+          </a:prstGeom>
+          <a:noFill/>
+          <a:ln/>
+        </p:spPr>
+        <p:txBody>
+          <a:bodyPr wrap="square" lIns="0" tIns="0" rIns="0" bIns="0" rtlCol="0" anchor="ctr"/>
+          <a:lstStyle/>
+          <a:p>
+            <a:pPr algn="ctr" indent="0" marL="0">
+              <a:buNone/>
+            </a:pPr>
+            <a:r>
+              <a:rPr lang="en-US" sz="800" dirty="0">
+                <a:solidFill>
+                  <a:srgbClr val="64748B"/>
+                </a:solidFill>
+                <a:latin typeface="Calibri" pitchFamily="34" charset="0"/>
+              </a:rPr>
+              <a:t>Mar 15 – Apr 2026</a:t>
+            </a:r>
+          </a:p>
+        </p:txBody>
+      </p:sp>
+      <p:sp>
+        <p:nvSpPr>
+          <p:cNvPr id="20" name="DateP2"/>
+          <p:cNvSpPr/>
+          <p:nvPr/>
+        </p:nvSpPr>
+        <p:spPr>
+          <a:xfrm>
+            <a:off x="2139600" y="2650000"/>
+            <a:ext cx="1820000" cy="220000"/>
+          </a:xfrm>
+          <a:prstGeom prst="rect">
+            <a:avLst/>
+          </a:prstGeom>
+          <a:noFill/>
+          <a:ln/>
+        </p:spPr>
+        <p:txBody>
+          <a:bodyPr wrap="square" lIns="0" tIns="0" rIns="0" bIns="0" rtlCol="0" anchor="ctr"/>
+          <a:lstStyle/>
+          <a:p>
+            <a:pPr algn="ctr" indent="0" marL="0">
+              <a:buNone/>
+            </a:pPr>
+            <a:r>
+              <a:rPr lang="en-US" sz="800" dirty="0">
+                <a:solidFill>
+                  <a:srgbClr val="64748B"/>
+                </a:solidFill>
+                <a:latin typeface="Calibri" pitchFamily="34" charset="0"/>
+              </a:rPr>
+              <a:t>May – Aug 2026</a:t>
+            </a:r>
+          </a:p>
+        </p:txBody>
+      </p:sp>
+      <p:sp>
+        <p:nvSpPr>
+          <p:cNvPr id="21" name="DateP3"/>
+          <p:cNvSpPr/>
+          <p:nvPr/>
+        </p:nvSpPr>
+        <p:spPr>
+          <a:xfrm>
+            <a:off x="4142000" y="2650000"/>
+            <a:ext cx="1480000" cy="220000"/>
+          </a:xfrm>
+          <a:prstGeom prst="rect">
+            <a:avLst/>
+          </a:prstGeom>
+          <a:noFill/>
+          <a:ln/>
+        </p:spPr>
+        <p:txBody>
+          <a:bodyPr wrap="square" lIns="0" tIns="0" rIns="0" bIns="0" rtlCol="0" anchor="ctr"/>
+          <a:lstStyle/>
+          <a:p>
+            <a:pPr algn="ctr" indent="0" marL="0">
+              <a:buNone/>
+            </a:pPr>
+            <a:r>
+              <a:rPr lang="en-US" sz="800" dirty="0">
+                <a:solidFill>
+                  <a:srgbClr val="64748B"/>
+                </a:solidFill>
+                <a:latin typeface="Calibri" pitchFamily="34" charset="0"/>
+              </a:rPr>
+              <a:t>Sep – Oct 2026</a:t>
+            </a:r>
+          </a:p>
+        </p:txBody>
+      </p:sp>
+      <p:sp>
+        <p:nvSpPr>
+          <p:cNvPr id="22" name="DateP4"/>
+          <p:cNvSpPr/>
+          <p:nvPr/>
+        </p:nvSpPr>
+        <p:spPr>
+          <a:xfrm>
+            <a:off x="5804400" y="2650000"/>
+            <a:ext cx="1480000" cy="220000"/>
+          </a:xfrm>
+          <a:prstGeom prst="rect">
+            <a:avLst/>
+          </a:prstGeom>
+          <a:noFill/>
+          <a:ln/>
+        </p:spPr>
+        <p:txBody>
+          <a:bodyPr wrap="square" lIns="0" tIns="0" rIns="0" bIns="0" rtlCol="0" anchor="ctr"/>
+          <a:lstStyle/>
+          <a:p>
+            <a:pPr algn="ctr" indent="0" marL="0">
+              <a:buNone/>
+            </a:pPr>
+            <a:r>
+              <a:rPr lang="en-US" sz="800" dirty="0">
+                <a:solidFill>
+                  <a:srgbClr val="64748B"/>
+                </a:solidFill>
+                <a:latin typeface="Calibri" pitchFamily="34" charset="0"/>
+              </a:rPr>
+              <a:t>Nov – Dec 15, 2026</a:t>
+            </a:r>
+          </a:p>
+        </p:txBody>
+      </p:sp>
+      <p:sp>
+        <p:nvSpPr>
+          <p:cNvPr id="23" name="DateP5"/>
+          <p:cNvSpPr/>
+          <p:nvPr/>
+        </p:nvSpPr>
+        <p:spPr>
+          <a:xfrm>
+            <a:off x="7466800" y="2650000"/>
+            <a:ext cx="719800" cy="220000"/>
+          </a:xfrm>
+          <a:prstGeom prst="rect">
+            <a:avLst/>
+          </a:prstGeom>
+          <a:noFill/>
+          <a:ln/>
+        </p:spPr>
+        <p:txBody>
+          <a:bodyPr wrap="square" lIns="0" tIns="0" rIns="0" bIns="0" rtlCol="0" anchor="ctr"/>
+          <a:lstStyle/>
+          <a:p>
+            <a:pPr algn="ctr" indent="0" marL="0">
+              <a:buNone/>
+            </a:pPr>
+            <a:r>
+              <a:rPr lang="en-US" sz="800" b="1" dirty="0">
+                <a:solidFill>
+                  <a:srgbClr val="C9A44B"/>
+                </a:solidFill>
+                <a:latin typeface="Calibri" pitchFamily="34" charset="0"/>
+              </a:rPr>
+              <a:t>Dec 27</a:t>
+            </a:r>
+          </a:p>
+        </p:txBody>
+      </p:sp>
+      <p:sp>
+        <p:nvSpPr>
+          <p:cNvPr id="24" name="CardABG"/>
+          <p:cNvSpPr/>
+          <p:nvPr/>
+        </p:nvSpPr>
+        <p:spPr>
+          <a:xfrm>
+            <a:off x="457200" y="3000000"/>
+            <a:ext cx="2590000" cy="1637320"/>
+          </a:xfrm>
+          <a:prstGeom prst="rect">
+            <a:avLst/>
+          </a:prstGeom>
+          <a:solidFill>
+            <a:srgbClr val="0E1E38"/>
+          </a:solidFill>
+          <a:ln w="12700">
+            <a:solidFill>
+              <a:srgbClr val="1E3560"/>
+            </a:solidFill>
+            <a:prstDash val="solid"/>
+          </a:ln>
+          <a:effectLst>
+            <a:outerShdw sx="100000" sy="100000" kx="0" ky="0" algn="bl" rotWithShape="0" blurRad="127000" dist="38100" dir="8100000">
+              <a:srgbClr val="000000">
+                <a:alpha val="30000"/>
+              </a:srgbClr>
+            </a:outerShdw>
+          </a:effectLst>
+        </p:spPr>
+      </p:sp>
+      <p:sp>
+        <p:nvSpPr>
+          <p:cNvPr id="25" name="CardAAccent"/>
+          <p:cNvSpPr/>
+          <p:nvPr/>
+        </p:nvSpPr>
+        <p:spPr>
+          <a:xfrm>
+            <a:off x="457200" y="3000000"/>
+            <a:ext cx="50292" cy="1637320"/>
+          </a:xfrm>
+          <a:prstGeom prst="rect">
+            <a:avLst/>
+          </a:prstGeom>
+          <a:solidFill>
+            <a:srgbClr val="38BDF8"/>
+          </a:solidFill>
+          <a:ln w="12700">
+            <a:solidFill>
+              <a:srgbClr val="38BDF8"/>
+            </a:solidFill>
+            <a:prstDash val="solid"/>
+          </a:ln>
+        </p:spPr>
+      </p:sp>
+      <p:sp>
+        <p:nvSpPr>
+          <p:cNvPr id="26" name="CardAText"/>
+          <p:cNvSpPr/>
+          <p:nvPr/>
+        </p:nvSpPr>
+        <p:spPr>
+          <a:xfrm>
+            <a:off x="600000" y="3060000"/>
+            <a:ext cx="2350000" cy="1500000"/>
+          </a:xfrm>
+          <a:prstGeom prst="rect">
+            <a:avLst/>
+          </a:prstGeom>
+          <a:noFill/>
+          <a:ln/>
+        </p:spPr>
+        <p:txBody>
+          <a:bodyPr wrap="square" lIns="0" tIns="0" rIns="0" bIns="0" rtlCol="0" anchor="t"/>
+          <a:lstStyle/>
+          <a:p>
+            <a:pPr algn="l" indent="0" marL="0">
+              <a:buNone/>
+            </a:pPr>
+            <a:r>
+              <a:rPr lang="en-US" sz="1000" b="1" dirty="0">
+                <a:solidFill>
+                  <a:srgbClr val="F1F5F9"/>
+                </a:solidFill>
+                <a:latin typeface="Calibri" pitchFamily="34" charset="0"/>
+              </a:rPr>
+              <a:t>Pre-Conditions (Mar–Apr)</a:t>
+            </a:r>
+          </a:p>
+          <a:p>
+            <a:pPr algn="l" indent="0" marL="0">
+              <a:buNone/>
+            </a:pPr>
+            <a:endParaRPr lang="en-US" sz="800" dirty="0"/>
+          </a:p>
+          <a:p>
+            <a:pPr algn="l" indent="0" marL="0">
+              <a:buNone/>
+            </a:pPr>
+            <a:r>
+              <a:rPr lang="en-US" sz="900" dirty="0">
+                <a:solidFill>
+                  <a:srgbClr val="94A3B8"/>
+                </a:solidFill>
+                <a:latin typeface="Calibri" pitchFamily="34" charset="0"/>
+              </a:rPr>
+              <a:t>Contract signed. DoA matrix built (governance pre-req, not ERP task). France vendor master cleanup complete. Blueprint kickoff readiness confirmed.</a:t>
+            </a:r>
+          </a:p>
+        </p:txBody>
+      </p:sp>
+      <p:sp>
+        <p:nvSpPr>
+          <p:cNvPr id="27" name="CardBBG"/>
+          <p:cNvSpPr/>
+          <p:nvPr/>
+        </p:nvSpPr>
+        <p:spPr>
+          <a:xfrm>
+            <a:off x="3261800" y="3000000"/>
+            <a:ext cx="2590000" cy="1637320"/>
+          </a:xfrm>
+          <a:prstGeom prst="rect">
+            <a:avLst/>
+          </a:prstGeom>
+          <a:solidFill>
+            <a:srgbClr val="0E1E38"/>
+          </a:solidFill>
+          <a:ln w="12700">
+            <a:solidFill>
+              <a:srgbClr val="1E3560"/>
+            </a:solidFill>
+            <a:prstDash val="solid"/>
+          </a:ln>
+          <a:effectLst>
+            <a:outerShdw sx="100000" sy="100000" kx="0" ky="0" algn="bl" rotWithShape="0" blurRad="127000" dist="38100" dir="8100000">
+              <a:srgbClr val="000000">
+                <a:alpha val="30000"/>
+              </a:srgbClr>
+            </a:outerShdw>
+          </a:effectLst>
+        </p:spPr>
+      </p:sp>
+      <p:sp>
+        <p:nvSpPr>
+          <p:cNvPr id="28" name="CardBAccent"/>
+          <p:cNvSpPr/>
+          <p:nvPr/>
+        </p:nvSpPr>
+        <p:spPr>
+          <a:xfrm>
+            <a:off x="3261800" y="3000000"/>
+            <a:ext cx="50292" cy="1637320"/>
+          </a:xfrm>
+          <a:prstGeom prst="rect">
+            <a:avLst/>
+          </a:prstGeom>
+          <a:solidFill>
+            <a:srgbClr val="C9A44B"/>
+          </a:solidFill>
+          <a:ln w="12700">
+            <a:solidFill>
+              <a:srgbClr val="C9A44B"/>
+            </a:solidFill>
+            <a:prstDash val="solid"/>
+          </a:ln>
+        </p:spPr>
+      </p:sp>
+      <p:sp>
+        <p:nvSpPr>
+          <p:cNvPr id="29" name="CardBText"/>
+          <p:cNvSpPr/>
+          <p:nvPr/>
+        </p:nvSpPr>
+        <p:spPr>
+          <a:xfrm>
+            <a:off x="3400000" y="3060000"/>
+            <a:ext cx="2350000" cy="1500000"/>
+          </a:xfrm>
+          <a:prstGeom prst="rect">
+            <a:avLst/>
+          </a:prstGeom>
+          <a:noFill/>
+          <a:ln/>
+        </p:spPr>
+        <p:txBody>
+          <a:bodyPr wrap="square" lIns="0" tIns="0" rIns="0" bIns="0" rtlCol="0" anchor="t"/>
+          <a:lstStyle/>
+          <a:p>
+            <a:pPr algn="l" indent="0" marL="0">
+              <a:buNone/>
+            </a:pPr>
+            <a:r>
+              <a:rPr lang="en-US" sz="1000" b="1" dirty="0">
+                <a:solidFill>
+                  <a:srgbClr val="F1F5F9"/>
+                </a:solidFill>
+                <a:latin typeface="Calibri" pitchFamily="34" charset="0"/>
+              </a:rPr>
+              <a:t>Internal Resource Requirement</a:t>
+            </a:r>
+          </a:p>
+          <a:p>
+            <a:pPr algn="l" indent="0" marL="0">
+              <a:buNone/>
+            </a:pPr>
+            <a:endParaRPr lang="en-US" sz="800" dirty="0"/>
+          </a:p>
+          <a:p>
+            <a:pPr algn="l" indent="0" marL="0">
+              <a:buNone/>
+            </a:pPr>
+            <a:r>
+              <a:rPr lang="en-US" sz="900" dirty="0">
+                <a:solidFill>
+                  <a:srgbClr val="94A3B8"/>
+                </a:solidFill>
+                <a:latin typeface="Calibri" pitchFamily="34" charset="0"/>
+              </a:rPr>
+              <a:t>Executive Sponsor: 0–4 hrs/wk. ERP Program Manager: 4–8 hrs/wk. Finance &amp; IT Process Leads: 4–8+ hrs/wk during configure and test phases. NetSuite provides implementation team.</a:t>
+            </a:r>
+          </a:p>
+        </p:txBody>
+      </p:sp>
+      <p:sp>
+        <p:nvSpPr>
+          <p:cNvPr id="30" name="CardCBG"/>
+          <p:cNvSpPr/>
+          <p:nvPr/>
+        </p:nvSpPr>
+        <p:spPr>
+          <a:xfrm>
+            <a:off x="6066400" y="3000000"/>
+            <a:ext cx="2590000" cy="1637320"/>
+          </a:xfrm>
+          <a:prstGeom prst="rect">
+            <a:avLst/>
+          </a:prstGeom>
+          <a:solidFill>
+            <a:srgbClr val="0E1E38"/>
+          </a:solidFill>
+          <a:ln w="12700">
+            <a:solidFill>
+              <a:srgbClr val="1E3560"/>
+            </a:solidFill>
+            <a:prstDash val="solid"/>
+          </a:ln>
+          <a:effectLst>
+            <a:outerShdw sx="100000" sy="100000" kx="0" ky="0" algn="bl" rotWithShape="0" blurRad="127000" dist="38100" dir="8100000">
+              <a:srgbClr val="000000">
+                <a:alpha val="30000"/>
+              </a:srgbClr>
+            </a:outerShdw>
+          </a:effectLst>
+        </p:spPr>
+      </p:sp>
+      <p:sp>
+        <p:nvSpPr>
+          <p:cNvPr id="31" name="CardCAccent"/>
+          <p:cNvSpPr/>
+          <p:nvPr/>
+        </p:nvSpPr>
+        <p:spPr>
+          <a:xfrm>
+            <a:off x="6066400" y="3000000"/>
+            <a:ext cx="50292" cy="1637320"/>
+          </a:xfrm>
+          <a:prstGeom prst="rect">
+            <a:avLst/>
+          </a:prstGeom>
+          <a:solidFill>
+            <a:srgbClr val="10B981"/>
+          </a:solidFill>
+          <a:ln w="12700">
+            <a:solidFill>
+              <a:srgbClr val="10B981"/>
+            </a:solidFill>
+            <a:prstDash val="solid"/>
+          </a:ln>
+        </p:spPr>
+      </p:sp>
+      <p:sp>
+        <p:nvSpPr>
+          <p:cNvPr id="32" name="CardCText"/>
+          <p:cNvSpPr/>
+          <p:nvPr/>
+        </p:nvSpPr>
+        <p:spPr>
+          <a:xfrm>
+            <a:off x="6205000" y="3060000"/>
+            <a:ext cx="2350000" cy="1500000"/>
+          </a:xfrm>
+          <a:prstGeom prst="rect">
+            <a:avLst/>
+          </a:prstGeom>
+          <a:noFill/>
+          <a:ln/>
+        </p:spPr>
+        <p:txBody>
+          <a:bodyPr wrap="square" lIns="0" tIns="0" rIns="0" bIns="0" rtlCol="0" anchor="t"/>
+          <a:lstStyle/>
+          <a:p>
+            <a:pPr algn="l" indent="0" marL="0">
+              <a:buNone/>
+            </a:pPr>
+            <a:r>
+              <a:rPr lang="en-US" sz="1000" b="1" dirty="0">
+                <a:solidFill>
+                  <a:srgbClr val="F1F5F9"/>
+                </a:solidFill>
+                <a:latin typeface="Calibri" pitchFamily="34" charset="0"/>
+              </a:rPr>
+              <a:t>Go-Live Constraints</a:t>
+            </a:r>
+          </a:p>
+          <a:p>
+            <a:pPr algn="l" indent="0" marL="0">
+              <a:buNone/>
+            </a:pPr>
+            <a:endParaRPr lang="en-US" sz="800" dirty="0"/>
+          </a:p>
+          <a:p>
+            <a:pPr algn="l" indent="0" marL="0">
+              <a:buNone/>
+            </a:pPr>
+            <a:r>
+              <a:rPr lang="en-US" sz="900" dirty="0">
+                <a:solidFill>
+                  <a:srgbClr val="94A3B8"/>
+                </a:solidFill>
+                <a:latin typeface="Calibri" pitchFamily="34" charset="0"/>
+              </a:rPr>
+              <a:t>January 1, 2027 is non-negotiable. December 27, 2026 target preserves buffer. Tied to US public market launch December 2027. Sage 100 decommission follows go-live stabilization.</a:t>
+            </a:r>
+          </a:p>
+        </p:txBody>
+      </p:sp>
+      <p:sp>
+        <p:nvSpPr>
+          <p:cNvPr id="33" name="FooterBar"/>
+          <p:cNvSpPr/>
+          <p:nvPr/>
+        </p:nvSpPr>
+        <p:spPr>
+          <a:xfrm>
+            <a:off x="0" y="4846320"/>
+            <a:ext cx="9144000" cy="297180"/>
+          </a:xfrm>
+          <a:prstGeom prst="rect">
+            <a:avLst/>
+          </a:prstGeom>
+          <a:solidFill>
+            <a:srgbClr val="142238"/>
+          </a:solidFill>
+          <a:ln w="12700">
+            <a:solidFill>
+              <a:srgbClr val="142238"/>
+            </a:solidFill>
+            <a:prstDash val="solid"/>
+          </a:ln>
+        </p:spPr>
+      </p:sp>
+      <p:sp>
+        <p:nvSpPr>
+          <p:cNvPr id="34" name="FooterPageNum"/>
+          <p:cNvSpPr/>
+          <p:nvPr/>
+        </p:nvSpPr>
+        <p:spPr>
+          <a:xfrm>
+            <a:off x="0" y="4846320"/>
+            <a:ext cx="8869680" cy="297180"/>
+          </a:xfrm>
+          <a:prstGeom prst="rect">
+            <a:avLst/>
+          </a:prstGeom>
+          <a:noFill/>
+          <a:ln/>
+        </p:spPr>
+        <p:txBody>
+          <a:bodyPr wrap="square" lIns="0" tIns="0" rIns="0" bIns="0" rtlCol="0" anchor="ctr"/>
+          <a:lstStyle/>
+          <a:p>
+            <a:pPr algn="r" indent="0" marL="0">
+              <a:buNone/>
+            </a:pPr>
+            <a:r>
+              <a:rPr lang="en-US" sz="900" dirty="0">
+                <a:solidFill>
+                  <a:srgbClr val="64748B"/>
+                </a:solidFill>
+                <a:latin typeface="Calibri" pitchFamily="34" charset="0"/>
+              </a:rPr>
+              <a:t>3 / 9</a:t>
+            </a:r>
+          </a:p>
+        </p:txBody>
+      </p:sp>
+      <p:sp>
+        <p:nvSpPr>
+          <p:cNvPr id="35" name="FooterLabel"/>
+          <p:cNvSpPr/>
+          <p:nvPr/>
+        </p:nvSpPr>
+        <p:spPr>
+          <a:xfrm>
+            <a:off x="274320" y="4846320"/>
+            <a:ext cx="5486400" cy="297180"/>
+          </a:xfrm>
+          <a:prstGeom prst="rect">
+            <a:avLst/>
+          </a:prstGeom>
+          <a:noFill/>
+          <a:ln/>
+        </p:spPr>
+        <p:txBody>
+          <a:bodyPr wrap="square" lIns="0" tIns="0" rIns="0" bIns="0" rtlCol="0" anchor="ctr"/>
+          <a:lstStyle/>
+          <a:p>
+            <a:pPr algn="l" indent="0" marL="0">
+              <a:buNone/>
+            </a:pPr>
+            <a:r>
+              <a:rPr lang="en-US" sz="900" dirty="0">
+                <a:solidFill>
+                  <a:srgbClr val="64748B"/>
+                </a:solidFill>
+                <a:latin typeface="Calibri" pitchFamily="34" charset="0"/>
+              </a:rPr>
+              <a:t>Audit Committee ERP Controls Readout  ·  March 2026</a:t>
+            </a:r>
+          </a:p>
+        </p:txBody>
+      </p:sp>
+    </p:spTree>
+  </p:cSld>
+  <p:clrMapOvr>
+    <a:masterClrMapping/>
+  </p:clrMapOvr>
+</p:sld>
+</file>
+
+<file path=ppt/slides/slide9.xml><?xml version="1.0" encoding="utf-8"?>
+<p:sld xmlns:a="http://schemas.openxmlformats.org/drawingml/2006/main" xmlns:r="http://schemas.openxmlformats.org/officeDocument/2006/relationships" xmlns:p="http://schemas.openxmlformats.org/presentationml/2006/main">
+  <p:cSld name="Commercial and Resourcing">
+    <p:bg>
+      <p:bgPr>
+        <a:solidFill>
+          <a:srgbClr val="080E1C"/>
+        </a:solidFill>
+      </p:bgPr>
+    </p:bg>
+    <p:spTree>
+      <p:nvGrpSpPr>
+        <p:cNvPr id="1" name=""/>
+        <p:cNvGrpSpPr/>
+        <p:nvPr/>
+      </p:nvGrpSpPr>
+      <p:grpSpPr>
+        <a:xfrm>
+          <a:off x="0" y="0"/>
+          <a:ext cx="0" cy="0"/>
+          <a:chOff x="0" y="0"/>
+          <a:chExt cx="0" cy="0"/>
+        </a:xfrm>
+      </p:grpSpPr>
+      <p:sp>
+        <p:nvSpPr>
+          <p:cNvPr id="2" name="HeaderBar"/>
+          <p:cNvSpPr/>
+          <p:nvPr/>
+        </p:nvSpPr>
+        <p:spPr>
+          <a:xfrm>
+            <a:off x="0" y="0"/>
+            <a:ext cx="9144000" cy="658368"/>
+          </a:xfrm>
+          <a:prstGeom prst="rect">
+            <a:avLst/>
+          </a:prstGeom>
+          <a:solidFill>
+            <a:srgbClr val="142238"/>
+          </a:solidFill>
+          <a:ln w="12700">
+            <a:solidFill>
+              <a:srgbClr val="142238"/>
+            </a:solidFill>
+            <a:prstDash val="solid"/>
+          </a:ln>
+        </p:spPr>
+      </p:sp>
+      <p:sp>
+        <p:nvSpPr>
+          <p:cNvPr id="3" name="GoldStrip"/>
+          <p:cNvSpPr/>
+          <p:nvPr/>
+        </p:nvSpPr>
+        <p:spPr>
+          <a:xfrm>
+            <a:off x="0" y="0"/>
+            <a:ext cx="54864" cy="658368"/>
+          </a:xfrm>
+          <a:prstGeom prst="rect">
+            <a:avLst/>
+          </a:prstGeom>
+          <a:solidFill>
+            <a:srgbClr val="C9A44B"/>
+          </a:solidFill>
+          <a:ln w="12700">
+            <a:solidFill>
+              <a:srgbClr val="C9A44B"/>
+            </a:solidFill>
+            <a:prstDash val="solid"/>
+          </a:ln>
+        </p:spPr>
+      </p:sp>
+      <p:sp>
+        <p:nvSpPr>
+          <p:cNvPr id="4" name="HeaderLeft"/>
+          <p:cNvSpPr/>
+          <p:nvPr/>
+        </p:nvSpPr>
+        <p:spPr>
+          <a:xfrm>
+            <a:off x="164592" y="0"/>
+            <a:ext cx="5486400" cy="658368"/>
+          </a:xfrm>
+          <a:prstGeom prst="rect">
+            <a:avLst/>
+          </a:prstGeom>
+          <a:noFill/>
+          <a:ln/>
+        </p:spPr>
+        <p:txBody>
+          <a:bodyPr wrap="square" lIns="0" tIns="0" rIns="0" bIns="0" rtlCol="0" anchor="ctr"/>
+          <a:lstStyle/>
+          <a:p>
+            <a:pPr algn="l" indent="0" marL="0">
+              <a:buNone/>
+            </a:pPr>
+            <a:r>
+              <a:rPr lang="en-US" sz="900" spc="200" kern="0" dirty="0">
+                <a:solidFill>
+                  <a:srgbClr val="64748B"/>
+                </a:solidFill>
+                <a:latin typeface="Calibri" pitchFamily="34" charset="0"/>
+              </a:rPr>
+              <a:t>ABIVAX  ·  AUDIT COMMITTEE  ·  CONFIDENTIAL</a:t>
+            </a:r>
+          </a:p>
+        </p:txBody>
+      </p:sp>
+      <p:sp>
+        <p:nvSpPr>
+          <p:cNvPr id="5" name="HeaderRight"/>
+          <p:cNvSpPr/>
+          <p:nvPr/>
+        </p:nvSpPr>
+        <p:spPr>
+          <a:xfrm>
+            <a:off x="5486400" y="0"/>
+            <a:ext cx="3474720" cy="658368"/>
+          </a:xfrm>
+          <a:prstGeom prst="rect">
+            <a:avLst/>
+          </a:prstGeom>
+          <a:noFill/>
+          <a:ln/>
+        </p:spPr>
+        <p:txBody>
+          <a:bodyPr wrap="square" lIns="0" tIns="0" rIns="0" bIns="0" rtlCol="0" anchor="ctr"/>
+          <a:lstStyle/>
+          <a:p>
+            <a:pPr algn="r" indent="0" marL="0">
+              <a:buNone/>
+            </a:pPr>
+            <a:r>
+              <a:rPr lang="en-US" sz="900" dirty="0">
+                <a:solidFill>
+                  <a:srgbClr val="94A3B8"/>
+                </a:solidFill>
+                <a:latin typeface="Calibri" pitchFamily="34" charset="0"/>
+              </a:rPr>
+              <a:t>Commercials · Slide 4 of 9</a:t>
+            </a:r>
+          </a:p>
+        </p:txBody>
+      </p:sp>
+      <p:sp>
+        <p:nvSpPr>
+          <p:cNvPr id="6" name="SlideTitle"/>
+          <p:cNvSpPr/>
+          <p:nvPr/>
+        </p:nvSpPr>
+        <p:spPr>
+          <a:xfrm>
+            <a:off x="457200" y="749808"/>
+            <a:ext cx="8229600" cy="548640"/>
+          </a:xfrm>
+          <a:prstGeom prst="rect">
+            <a:avLst/>
+          </a:prstGeom>
+          <a:noFill/>
+          <a:ln/>
+        </p:spPr>
+        <p:txBody>
+          <a:bodyPr wrap="square" lIns="0" tIns="0" rIns="0" bIns="0" rtlCol="0" anchor="ctr"/>
+          <a:lstStyle/>
+          <a:p>
+            <a:pPr algn="l" indent="0" marL="0">
+              <a:buNone/>
+            </a:pPr>
+            <a:r>
+              <a:rPr lang="en-US" sz="2200" b="1" dirty="0">
+                <a:solidFill>
+                  <a:srgbClr val="F1F5F9"/>
+                </a:solidFill>
+                <a:latin typeface="Georgia" pitchFamily="34" charset="0"/>
+              </a:rPr>
+              <a:t>Commercial &amp; Resourcing Model</a:t>
+            </a:r>
+          </a:p>
+        </p:txBody>
+      </p:sp>
+      <p:sp>
+        <p:nvSpPr>
+          <p:cNvPr id="7" name="Subtitle"/>
+          <p:cNvSpPr/>
+          <p:nvPr/>
+        </p:nvSpPr>
+        <p:spPr>
+          <a:xfrm>
+            <a:off x="457200" y="1371600"/>
+            <a:ext cx="8229600" cy="256032"/>
+          </a:xfrm>
+          <a:prstGeom prst="rect">
+            <a:avLst/>
+          </a:prstGeom>
+          <a:noFill/>
+          <a:ln/>
+        </p:spPr>
+        <p:txBody>
+          <a:bodyPr wrap="square" lIns="0" tIns="0" rIns="0" bIns="0" rtlCol="0" anchor="ctr"/>
+          <a:lstStyle/>
+          <a:p>
+            <a:pPr algn="l" indent="0" marL="0">
+              <a:buNone/>
+            </a:pPr>
+            <a:r>
+              <a:rPr lang="en-US" sz="1100" dirty="0">
+                <a:solidFill>
+                  <a:srgbClr val="94A3B8"/>
+                </a:solidFill>
+                <a:latin typeface="Calibri" pitchFamily="34" charset="0"/>
+              </a:rPr>
+              <a:t>Year 1 investment estimate ~$1M. Owners: Mike Markman (ERP Lead) + Hema Keshava (CFO/Sponsor). Final contract values pending close of commercial negotiation.</a:t>
+            </a:r>
+          </a:p>
+        </p:txBody>
+      </p:sp>
+      <p:sp>
+        <p:nvSpPr>
+          <p:cNvPr id="8" name="Card1BG"/>
+          <p:cNvSpPr/>
+          <p:nvPr/>
+        </p:nvSpPr>
+        <p:spPr>
+          <a:xfrm>
+            <a:off x="457200" y="1737360"/>
+            <a:ext cx="3900000" cy="2900000"/>
+          </a:xfrm>
+          <a:prstGeom prst="rect">
+            <a:avLst/>
+          </a:prstGeom>
+          <a:solidFill>
+            <a:srgbClr val="0E1E38"/>
+          </a:solidFill>
+          <a:ln w="12700">
+            <a:solidFill>
+              <a:srgbClr val="1E3560"/>
+            </a:solidFill>
+            <a:prstDash val="solid"/>
+          </a:ln>
+          <a:effectLst>
+            <a:outerShdw sx="100000" sy="100000" kx="0" ky="0" algn="bl" rotWithShape="0" blurRad="127000" dist="38100" dir="8100000">
+              <a:srgbClr val="000000">
+                <a:alpha val="30000"/>
+              </a:srgbClr>
+            </a:outerShdw>
+          </a:effectLst>
+        </p:spPr>
+      </p:sp>
+      <p:sp>
+        <p:nvSpPr>
+          <p:cNvPr id="9" name="Card1Accent"/>
+          <p:cNvSpPr/>
+          <p:nvPr/>
+        </p:nvSpPr>
+        <p:spPr>
+          <a:xfrm>
+            <a:off x="457200" y="1737360"/>
+            <a:ext cx="50292" cy="2900000"/>
+          </a:xfrm>
+          <a:prstGeom prst="rect">
+            <a:avLst/>
+          </a:prstGeom>
+          <a:solidFill>
+            <a:srgbClr val="C9A44B"/>
+          </a:solidFill>
+          <a:ln w="12700">
+            <a:solidFill>
+              <a:srgbClr val="C9A44B"/>
+            </a:solidFill>
+            <a:prstDash val="solid"/>
+          </a:ln>
+        </p:spPr>
+      </p:sp>
+      <p:sp>
+        <p:nvSpPr>
+          <p:cNvPr id="10" name="Card1Text"/>
+          <p:cNvSpPr/>
+          <p:nvPr/>
+        </p:nvSpPr>
+        <p:spPr>
+          <a:xfrm>
+            <a:off x="600000" y="1800000"/>
+            <a:ext cx="3650000" cy="2800000"/>
+          </a:xfrm>
+          <a:prstGeom prst="rect">
+            <a:avLst/>
+          </a:prstGeom>
+          <a:noFill/>
+          <a:ln/>
+        </p:spPr>
+        <p:txBody>
+          <a:bodyPr wrap="square" lIns="0" tIns="0" rIns="0" bIns="0" rtlCol="0" anchor="t"/>
+          <a:lstStyle/>
+          <a:p>
+            <a:pPr algn="l" indent="0" marL="0">
+              <a:buNone/>
+            </a:pPr>
+            <a:r>
+              <a:rPr lang="en-US" sz="1100" b="1" dirty="0">
+                <a:solidFill>
+                  <a:srgbClr val="C9A44B"/>
+                </a:solidFill>
+                <a:latin typeface="Georgia" pitchFamily="34" charset="0"/>
+              </a:rPr>
+              <a:t>Year 1 Investment View</a:t>
+            </a:r>
+          </a:p>
+          <a:p>
+            <a:pPr algn="l" indent="0" marL="0">
+              <a:buNone/>
+            </a:pPr>
+            <a:endParaRPr lang="en-US" sz="800" dirty="0"/>
+          </a:p>
+          <a:p>
+            <a:pPr algn="l" indent="0" marL="0">
+              <a:buNone/>
+            </a:pPr>
+            <a:r>
+              <a:rPr lang="en-US" sz="900" b="1" dirty="0">
+                <a:solidFill>
+                  <a:srgbClr val="F1F5F9"/>
+                </a:solidFill>
+                <a:latin typeface="Calibri" pitchFamily="34" charset="0"/>
+              </a:rPr>
+              <a:t>NetSuite License &amp; Implementation</a:t>
+            </a:r>
+          </a:p>
+          <a:p>
+            <a:pPr algn="l" indent="0" marL="0">
+              <a:buNone/>
+            </a:pPr>
+            <a:r>
+              <a:rPr lang="en-US" sz="900" dirty="0">
+                <a:solidFill>
+                  <a:srgbClr val="94A3B8"/>
+                </a:solidFill>
+                <a:latin typeface="Calibri" pitchFamily="34" charset="0"/>
+              </a:rPr>
+              <a:t>Subscription + implementation services package. Contract values pending commercial close. ~$1M Year 1 assumption built into budget planning.</a:t>
+            </a:r>
+          </a:p>
+          <a:p>
+            <a:pPr algn="l" indent="0" marL="0">
+              <a:buNone/>
+            </a:pPr>
+            <a:endParaRPr lang="en-US" sz="800" dirty="0"/>
+          </a:p>
+          <a:p>
+            <a:pPr algn="l" indent="0" marL="0">
+              <a:buNone/>
+            </a:pPr>
+            <a:r>
+              <a:rPr lang="en-US" sz="900" b="1" dirty="0">
+                <a:solidFill>
+                  <a:srgbClr val="F1F5F9"/>
+                </a:solidFill>
+                <a:latin typeface="Calibri" pitchFamily="34" charset="0"/>
+              </a:rPr>
+              <a:t>Key Integrations (from NetSuite Interfaces XLSX)</a:t>
+            </a:r>
+          </a:p>
+          <a:p>
+            <a:pPr algn="l" indent="0" marL="0">
+              <a:buNone/>
+            </a:pPr>
+            <a:r>
+              <a:rPr lang="en-US" sz="900" dirty="0">
+                <a:solidFill>
+                  <a:srgbClr val="94A3B8"/>
+                </a:solidFill>
+                <a:latin typeface="Calibri" pitchFamily="34" charset="0"/>
+              </a:rPr>
+              <a:t>Trustpair (vendor validation): API via NS Integration Platform — included in base. Agicap (cash flow): Free SuiteApp. Workiva (reporting): €3,200/yr additional license. All other integrations included in implementation scope.</a:t>
+            </a:r>
+          </a:p>
+          <a:p>
+            <a:pPr algn="l" indent="0" marL="0">
+              <a:buNone/>
+            </a:pPr>
+            <a:endParaRPr lang="en-US" sz="800" dirty="0"/>
+          </a:p>
+          <a:p>
+            <a:pPr algn="l" indent="0" marL="0">
+              <a:buNone/>
+            </a:pPr>
+            <a:r>
+              <a:rPr lang="en-US" sz="900" b="1" dirty="0">
+                <a:solidFill>
+                  <a:srgbClr val="F1F5F9"/>
+                </a:solidFill>
+                <a:latin typeface="Calibri" pitchFamily="34" charset="0"/>
+              </a:rPr>
+              <a:t>Year 2+ Assumptions</a:t>
+            </a:r>
+          </a:p>
+          <a:p>
+            <a:pPr algn="l" indent="0" marL="0">
+              <a:buNone/>
+            </a:pPr>
+            <a:r>
+              <a:rPr lang="en-US" sz="900" dirty="0">
+                <a:solidFill>
+                  <a:srgbClr val="94A3B8"/>
+                </a:solidFill>
+                <a:latin typeface="Calibri" pitchFamily="34" charset="0"/>
+              </a:rPr>
+              <a:t>Annual subscription renewals. Post-go-live optimization and Phase 2 automation investment to be sized separately after January 1, 2027.</a:t>
+            </a:r>
+          </a:p>
+        </p:txBody>
+      </p:sp>
+      <p:sp>
+        <p:nvSpPr>
+          <p:cNvPr id="11" name="Card2BG"/>
+          <p:cNvSpPr/>
+          <p:nvPr/>
+        </p:nvSpPr>
+        <p:spPr>
+          <a:xfrm>
+            <a:off x="4586800" y="1737360"/>
+            <a:ext cx="3900000" cy="2900000"/>
+          </a:xfrm>
+          <a:prstGeom prst="rect">
+            <a:avLst/>
+          </a:prstGeom>
+          <a:solidFill>
+            <a:srgbClr val="0E1E38"/>
+          </a:solidFill>
+          <a:ln w="12700">
+            <a:solidFill>
+              <a:srgbClr val="1E3560"/>
+            </a:solidFill>
+            <a:prstDash val="solid"/>
+          </a:ln>
+          <a:effectLst>
+            <a:outerShdw sx="100000" sy="100000" kx="0" ky="0" algn="bl" rotWithShape="0" blurRad="127000" dist="38100" dir="8100000">
+              <a:srgbClr val="000000">
+                <a:alpha val="30000"/>
+              </a:srgbClr>
+            </a:outerShdw>
+          </a:effectLst>
+        </p:spPr>
+      </p:sp>
+      <p:sp>
+        <p:nvSpPr>
+          <p:cNvPr id="12" name="Card2Accent"/>
+          <p:cNvSpPr/>
+          <p:nvPr/>
+        </p:nvSpPr>
+        <p:spPr>
+          <a:xfrm>
+            <a:off x="4586800" y="1737360"/>
+            <a:ext cx="50292" cy="2900000"/>
+          </a:xfrm>
+          <a:prstGeom prst="rect">
+            <a:avLst/>
+          </a:prstGeom>
+          <a:solidFill>
+            <a:srgbClr val="38BDF8"/>
+          </a:solidFill>
+          <a:ln w="12700">
+            <a:solidFill>
+              <a:srgbClr val="38BDF8"/>
+            </a:solidFill>
+            <a:prstDash val="solid"/>
+          </a:ln>
+        </p:spPr>
+      </p:sp>
+      <p:sp>
+        <p:nvSpPr>
+          <p:cNvPr id="13" name="Card2Text"/>
+          <p:cNvSpPr/>
+          <p:nvPr/>
+        </p:nvSpPr>
+        <p:spPr>
+          <a:xfrm>
+            <a:off x="4730000" y="1800000"/>
+            <a:ext cx="3650000" cy="2800000"/>
+          </a:xfrm>
+          <a:prstGeom prst="rect">
+            <a:avLst/>
+          </a:prstGeom>
+          <a:noFill/>
+          <a:ln/>
+        </p:spPr>
+        <p:txBody>
+          <a:bodyPr wrap="square" lIns="0" tIns="0" rIns="0" bIns="0" rtlCol="0" anchor="t"/>
+          <a:lstStyle/>
+          <a:p>
+            <a:pPr algn="l" indent="0" marL="0">
+              <a:buNone/>
+            </a:pPr>
+            <a:r>
+              <a:rPr lang="en-US" sz="1100" b="1" dirty="0">
+                <a:solidFill>
+                  <a:srgbClr val="38BDF8"/>
+                </a:solidFill>
+                <a:latin typeface="Georgia" pitchFamily="34" charset="0"/>
+              </a:rPr>
+              <a:t>Program Ownership &amp; Governance</a:t>
+            </a:r>
+          </a:p>
+          <a:p>
+            <a:pPr algn="l" indent="0" marL="0">
+              <a:buNone/>
+            </a:pPr>
+            <a:endParaRPr lang="en-US" sz="800" dirty="0"/>
+          </a:p>
+          <a:p>
+            <a:pPr algn="l" indent="0" marL="0">
+              <a:buNone/>
+            </a:pPr>
+            <a:r>
+              <a:rPr lang="en-US" sz="900" b="1" dirty="0">
+                <a:solidFill>
+                  <a:srgbClr val="F1F5F9"/>
+                </a:solidFill>
+                <a:latin typeface="Calibri" pitchFamily="34" charset="0"/>
+              </a:rPr>
+              <a:t>Internal Program Leads</a:t>
+            </a:r>
+          </a:p>
+          <a:p>
+            <a:pPr algn="l" indent="0" marL="0">
+              <a:buNone/>
+            </a:pPr>
+            <a:r>
+              <a:rPr lang="en-US" sz="900" dirty="0">
+                <a:solidFill>
+                  <a:srgbClr val="94A3B8"/>
+                </a:solidFill>
+                <a:latin typeface="Calibri" pitchFamily="34" charset="0"/>
+              </a:rPr>
+              <a:t>ERP Program Lead: Mike Markman (VP, Global ERP Lead). Executive Sponsor: Hema Keshava (CFO). Finance Process Lead: Trinidad Mesa (France). IT Lead: TBD. NetSuite provides dedicated implementation PM and functional consultants.</a:t>
+            </a:r>
+          </a:p>
+          <a:p>
+            <a:pPr algn="l" indent="0" marL="0">
+              <a:buNone/>
+            </a:pPr>
+            <a:endParaRPr lang="en-US" sz="800" dirty="0"/>
+          </a:p>
+          <a:p>
+            <a:pPr algn="l" indent="0" marL="0">
+              <a:buNone/>
+            </a:pPr>
+            <a:r>
+              <a:rPr lang="en-US" sz="900" b="1" dirty="0">
+                <a:solidFill>
+                  <a:srgbClr val="F1F5F9"/>
+                </a:solidFill>
+                <a:latin typeface="Calibri" pitchFamily="34" charset="0"/>
+              </a:rPr>
+              <a:t>Governance Cadence</a:t>
+            </a:r>
+          </a:p>
+          <a:p>
+            <a:pPr algn="l" indent="0" marL="0">
+              <a:buNone/>
+            </a:pPr>
+            <a:r>
+              <a:rPr lang="en-US" sz="900" dirty="0">
+                <a:solidFill>
+                  <a:srgbClr val="94A3B8"/>
+                </a:solidFill>
+                <a:latin typeface="Calibri" pitchFamily="34" charset="0"/>
+              </a:rPr>
+              <a:t>Weekly program cadence with milestone-triggered escalations. Monthly executive update to CFO. Board checkpoint at March 19 meeting. Audit Committee briefings at key control decision points.</a:t>
+            </a:r>
+          </a:p>
+          <a:p>
+            <a:pPr algn="l" indent="0" marL="0">
+              <a:buNone/>
+            </a:pPr>
+            <a:endParaRPr lang="en-US" sz="800" dirty="0"/>
+          </a:p>
+          <a:p>
+            <a:pPr algn="l" indent="0" marL="0">
+              <a:buNone/>
+            </a:pPr>
+            <a:r>
+              <a:rPr lang="en-US" sz="900" b="1" dirty="0">
+                <a:solidFill>
+                  <a:srgbClr val="F1F5F9"/>
+                </a:solidFill>
+                <a:latin typeface="Calibri" pitchFamily="34" charset="0"/>
+              </a:rPr>
+              <a:t>Note</a:t>
+            </a:r>
+          </a:p>
+          <a:p>
+            <a:pPr algn="l" indent="0" marL="0">
+              <a:buNone/>
+            </a:pPr>
+            <a:r>
+              <a:rPr lang="en-US" sz="900" dirty="0">
+                <a:solidFill>
+                  <a:srgbClr val="64748B"/>
+                </a:solidFill>
+                <a:latin typeface="Calibri" pitchFamily="34" charset="0"/>
+              </a:rPr>
+              <a:t>Commercial package finalization in progress. Final investment figures, detailed SOW, and contract terms will be shared with the Board at the March 19 meeting.</a:t>
+            </a:r>
+          </a:p>
+        </p:txBody>
+      </p:sp>
+      <p:sp>
+        <p:nvSpPr>
+          <p:cNvPr id="14" name="FooterBar"/>
+          <p:cNvSpPr/>
+          <p:nvPr/>
+        </p:nvSpPr>
+        <p:spPr>
+          <a:xfrm>
+            <a:off x="0" y="4846320"/>
+            <a:ext cx="9144000" cy="297180"/>
+          </a:xfrm>
+          <a:prstGeom prst="rect">
+            <a:avLst/>
+          </a:prstGeom>
+          <a:solidFill>
+            <a:srgbClr val="142238"/>
+          </a:solidFill>
+          <a:ln w="12700">
+            <a:solidFill>
+              <a:srgbClr val="142238"/>
+            </a:solidFill>
+            <a:prstDash val="solid"/>
+          </a:ln>
+        </p:spPr>
+      </p:sp>
+      <p:sp>
+        <p:nvSpPr>
+          <p:cNvPr id="15" name="FooterPageNum"/>
+          <p:cNvSpPr/>
+          <p:nvPr/>
+        </p:nvSpPr>
+        <p:spPr>
+          <a:xfrm>
+            <a:off x="0" y="4846320"/>
+            <a:ext cx="8869680" cy="297180"/>
+          </a:xfrm>
+          <a:prstGeom prst="rect">
+            <a:avLst/>
+          </a:prstGeom>
+          <a:noFill/>
+          <a:ln/>
+        </p:spPr>
+        <p:txBody>
+          <a:bodyPr wrap="square" lIns="0" tIns="0" rIns="0" bIns="0" rtlCol="0" anchor="ctr"/>
+          <a:lstStyle/>
+          <a:p>
+            <a:pPr algn="r" indent="0" marL="0">
+              <a:buNone/>
+            </a:pPr>
+            <a:r>
+              <a:rPr lang="en-US" sz="900" dirty="0">
+                <a:solidFill>
+                  <a:srgbClr val="64748B"/>
+                </a:solidFill>
+                <a:latin typeface="Calibri" pitchFamily="34" charset="0"/>
+              </a:rPr>
+              <a:t>4 / 9</a:t>
+            </a:r>
+          </a:p>
+        </p:txBody>
+      </p:sp>
+      <p:sp>
+        <p:nvSpPr>
+          <p:cNvPr id="16" name="FooterLabel"/>
+          <p:cNvSpPr/>
+          <p:nvPr/>
+        </p:nvSpPr>
+        <p:spPr>
+          <a:xfrm>
+            <a:off x="274320" y="4846320"/>
+            <a:ext cx="5486400" cy="297180"/>
+          </a:xfrm>
+          <a:prstGeom prst="rect">
+            <a:avLst/>
+          </a:prstGeom>
+          <a:noFill/>
+          <a:ln/>
+        </p:spPr>
+        <p:txBody>
+          <a:bodyPr wrap="square" lIns="0" tIns="0" rIns="0" bIns="0" rtlCol="0" anchor="ctr"/>
+          <a:lstStyle/>
+          <a:p>
+            <a:pPr algn="l" indent="0" marL="0">
+              <a:buNone/>
+            </a:pPr>
+            <a:r>
+              <a:rPr lang="en-US" sz="900" dirty="0">
+                <a:solidFill>
+                  <a:srgbClr val="64748B"/>
+                </a:solidFill>
+                <a:latin typeface="Calibri" pitchFamily="34" charset="0"/>
+              </a:rPr>
+              <a:t>Audit Committee ERP Controls Readout  ·  March 2026</a:t>
+            </a:r>
           </a:p>
         </p:txBody>
       </p:sp>

</xml_diff>

<commit_message>
WIP before resync to sanitized main
Checkpoint local changes prior to aligning main with sanitized origin/main history.

Made-with: Cursor
</commit_message>
<xml_diff>
--- a/outputs/Audit_Committee_ERP_Controls_Mar2026.pptx
+++ b/outputs/Audit_Committee_ERP_Controls_Mar2026.pptx
@@ -10739,7 +10739,7 @@
                 </a:solidFill>
                 <a:latin typeface="Calibri" pitchFamily="34" charset="0"/>
               </a:rPr>
-              <a:t>Year 1 investment estimate ~$1M. Owners: Mike Markman (ERP Lead) + Hema Keshava (CFO/Sponsor). Final contract values pending close of commercial negotiation.</a:t>
+              <a:t>Year 1 investment: €650K (€463K build + €187K run). 3-year total: €1.02M. Owners: Mike Markman (ERP Lead) + Hema Keshava (CFO/Sponsor). License and SOW in transit from Oracle.</a:t>
             </a:r>
           </a:p>
         </p:txBody>
@@ -10866,7 +10866,7 @@
                 </a:solidFill>
                 <a:latin typeface="Calibri" pitchFamily="34" charset="0"/>
               </a:rPr>
-              <a:t>Subscription + implementation services package. Contract values pending commercial close. ~$1M Year 1 assumption built into budget planning.</a:t>
+              <a:t>Year 1: €650,129 (€463,120 build + €187,009 run). 3-year total: €1,023,264. Figures confirmed by KPMG. License agreement and SOW in transit from Oracle. Commercial review underway — user counts, add-ons, and integration scope under negotiation.</a:t>
             </a:r>
           </a:p>
           <a:p>
@@ -11129,7 +11129,7 @@
                 </a:solidFill>
                 <a:latin typeface="Calibri" pitchFamily="34" charset="0"/>
               </a:rPr>
-              <a:t>Commercial package finalization in progress. Final investment figures, detailed SOW, and contract terms will be shared with the Board at the March 19 meeting.</a:t>
+              <a:t>KPMG-confirmed (Mar 3): Year 1 €650K, 3-year €1.02M. License agreement and SOW in transit from Oracle. Final commercial terms subject to ongoing negotiation — license scope and add-ons under review. Full package to be presented to Board at March 19 meeting.</a:t>
             </a:r>
           </a:p>
         </p:txBody>

</xml_diff>